<commit_message>
Recreations fidelity: connectors, xfrm, demos 01–26, visual audits
Add Connector begin/end connect and adj on bent connectors; get_or_add_xfrm;
Font/FillFormat fixes used by demos. Refresh fingerprint demos, templates,
out_mat2ppt packs, and visual_compare PNGs (05 thermometer visual_ok).
</commit_message>
<xml_diff>
--- a/examples/recreations/06_Box_Zeffy__Donation_Form_Question_Discrepencies_by_Link_Type_/out_mat2ppt.pptx
+++ b/examples/recreations/06_Box_Zeffy__Donation_Form_Question_Discrepencies_by_Link_Type_/out_mat2ppt.pptx
@@ -1,20 +1,20 @@
 
 <file path=ppt/presentation.xml><?xml version="1.0" encoding="utf-8"?>
-<p:presentation xmlns:a="http://schemas.openxmlformats.org/drawingml/2006/main" xmlns:r="http://schemas.openxmlformats.org/officeDocument/2006/relationships" xmlns:p="http://schemas.openxmlformats.org/presentationml/2006/main" saveSubsetFonts="1" autoCompressPictures="0">
+<p:presentation xmlns:a="http://schemas.openxmlformats.org/drawingml/2006/main" xmlns:r="http://schemas.openxmlformats.org/officeDocument/2006/relationships" xmlns:p="http://schemas.openxmlformats.org/presentationml/2006/main" saveSubsetFonts="1">
   <p:sldMasterIdLst>
     <p:sldMasterId id="2147483648" r:id="rId1"/>
   </p:sldMasterIdLst>
   <p:sldIdLst>
-    <p:sldId id="256" r:id="rId7"/>
-    <p:sldId id="257" r:id="rId8"/>
+    <p:sldId id="256" r:id="rId8"/>
+    <p:sldId id="257" r:id="rId9"/>
   </p:sldIdLst>
-  <p:sldSz cx="12192000" cy="6858000" type="screen4x3"/>
+  <p:sldSz cx="12192000" cy="6858000"/>
   <p:notesSz cx="6858000" cy="9144000"/>
   <p:defaultTextStyle>
     <a:defPPr>
       <a:defRPr lang="en-US"/>
     </a:defPPr>
-    <a:lvl1pPr marL="0" algn="l" defTabSz="457200" rtl="0" eaLnBrk="1" latinLnBrk="0" hangingPunct="1">
+    <a:lvl1pPr marL="0" algn="l" defTabSz="914400" rtl="0" eaLnBrk="1" latinLnBrk="0" hangingPunct="1">
       <a:defRPr sz="1800" kern="1200">
         <a:solidFill>
           <a:schemeClr val="tx1"/>
@@ -24,7 +24,7 @@
         <a:cs typeface="+mn-cs"/>
       </a:defRPr>
     </a:lvl1pPr>
-    <a:lvl2pPr marL="457200" algn="l" defTabSz="457200" rtl="0" eaLnBrk="1" latinLnBrk="0" hangingPunct="1">
+    <a:lvl2pPr marL="457200" algn="l" defTabSz="914400" rtl="0" eaLnBrk="1" latinLnBrk="0" hangingPunct="1">
       <a:defRPr sz="1800" kern="1200">
         <a:solidFill>
           <a:schemeClr val="tx1"/>
@@ -34,7 +34,7 @@
         <a:cs typeface="+mn-cs"/>
       </a:defRPr>
     </a:lvl2pPr>
-    <a:lvl3pPr marL="914400" algn="l" defTabSz="457200" rtl="0" eaLnBrk="1" latinLnBrk="0" hangingPunct="1">
+    <a:lvl3pPr marL="914400" algn="l" defTabSz="914400" rtl="0" eaLnBrk="1" latinLnBrk="0" hangingPunct="1">
       <a:defRPr sz="1800" kern="1200">
         <a:solidFill>
           <a:schemeClr val="tx1"/>
@@ -44,7 +44,7 @@
         <a:cs typeface="+mn-cs"/>
       </a:defRPr>
     </a:lvl3pPr>
-    <a:lvl4pPr marL="1371600" algn="l" defTabSz="457200" rtl="0" eaLnBrk="1" latinLnBrk="0" hangingPunct="1">
+    <a:lvl4pPr marL="1371600" algn="l" defTabSz="914400" rtl="0" eaLnBrk="1" latinLnBrk="0" hangingPunct="1">
       <a:defRPr sz="1800" kern="1200">
         <a:solidFill>
           <a:schemeClr val="tx1"/>
@@ -54,7 +54,7 @@
         <a:cs typeface="+mn-cs"/>
       </a:defRPr>
     </a:lvl4pPr>
-    <a:lvl5pPr marL="1828800" algn="l" defTabSz="457200" rtl="0" eaLnBrk="1" latinLnBrk="0" hangingPunct="1">
+    <a:lvl5pPr marL="1828800" algn="l" defTabSz="914400" rtl="0" eaLnBrk="1" latinLnBrk="0" hangingPunct="1">
       <a:defRPr sz="1800" kern="1200">
         <a:solidFill>
           <a:schemeClr val="tx1"/>
@@ -64,7 +64,7 @@
         <a:cs typeface="+mn-cs"/>
       </a:defRPr>
     </a:lvl5pPr>
-    <a:lvl6pPr marL="2286000" algn="l" defTabSz="457200" rtl="0" eaLnBrk="1" latinLnBrk="0" hangingPunct="1">
+    <a:lvl6pPr marL="2286000" algn="l" defTabSz="914400" rtl="0" eaLnBrk="1" latinLnBrk="0" hangingPunct="1">
       <a:defRPr sz="1800" kern="1200">
         <a:solidFill>
           <a:schemeClr val="tx1"/>
@@ -74,7 +74,7 @@
         <a:cs typeface="+mn-cs"/>
       </a:defRPr>
     </a:lvl6pPr>
-    <a:lvl7pPr marL="2743200" algn="l" defTabSz="457200" rtl="0" eaLnBrk="1" latinLnBrk="0" hangingPunct="1">
+    <a:lvl7pPr marL="2743200" algn="l" defTabSz="914400" rtl="0" eaLnBrk="1" latinLnBrk="0" hangingPunct="1">
       <a:defRPr sz="1800" kern="1200">
         <a:solidFill>
           <a:schemeClr val="tx1"/>
@@ -84,7 +84,7 @@
         <a:cs typeface="+mn-cs"/>
       </a:defRPr>
     </a:lvl7pPr>
-    <a:lvl8pPr marL="3200400" algn="l" defTabSz="457200" rtl="0" eaLnBrk="1" latinLnBrk="0" hangingPunct="1">
+    <a:lvl8pPr marL="3200400" algn="l" defTabSz="914400" rtl="0" eaLnBrk="1" latinLnBrk="0" hangingPunct="1">
       <a:defRPr sz="1800" kern="1200">
         <a:solidFill>
           <a:schemeClr val="tx1"/>
@@ -94,7 +94,7 @@
         <a:cs typeface="+mn-cs"/>
       </a:defRPr>
     </a:lvl8pPr>
-    <a:lvl9pPr marL="3657600" algn="l" defTabSz="457200" rtl="0" eaLnBrk="1" latinLnBrk="0" hangingPunct="1">
+    <a:lvl9pPr marL="3657600" algn="l" defTabSz="914400" rtl="0" eaLnBrk="1" latinLnBrk="0" hangingPunct="1">
       <a:defRPr sz="1800" kern="1200">
         <a:solidFill>
           <a:schemeClr val="tx1"/>
@@ -127,7 +127,13 @@
       </p:grpSpPr>
       <p:sp>
         <p:nvSpPr>
-          <p:cNvPr id="2" name="Title 1"/>
+          <p:cNvPr id="2" name="Title 1">
+            <a:extLst>
+              <a:ext uri="{FF2B5EF4-FFF2-40B4-BE49-F238E27FC236}">
+                <a16:creationId xmlns:a16="http://schemas.microsoft.com/office/drawing/2014/main" id="{182489A8-C68D-A31A-B463-8F1ACE714217}"/>
+              </a:ext>
+            </a:extLst>
+          </p:cNvPr>
           <p:cNvSpPr>
             <a:spLocks noGrp="1"/>
           </p:cNvSpPr>
@@ -137,25 +143,34 @@
         </p:nvSpPr>
         <p:spPr>
           <a:xfrm>
-            <a:off x="685800" y="2130425"/>
-            <a:ext cx="7772400" cy="1470025"/>
+            <a:off x="1524000" y="1122363"/>
+            <a:ext cx="9144000" cy="2387600"/>
           </a:xfrm>
         </p:spPr>
         <p:txBody>
-          <a:bodyPr/>
-          <a:lstStyle/>
-          <a:p>
-            <a:r>
-              <a:rPr lang="en-US" smtClean="0"/>
+          <a:bodyPr anchor="b"/>
+          <a:lstStyle>
+            <a:lvl1pPr algn="ctr">
+              <a:defRPr sz="6000"/>
+            </a:lvl1pPr>
+          </a:lstStyle>
+          <a:p>
+            <a:r>
+              <a:rPr lang="en-US"/>
               <a:t>Click to edit Master title style</a:t>
             </a:r>
-            <a:endParaRPr lang="en-US"/>
-          </a:p>
-        </p:txBody>
-      </p:sp>
-      <p:sp>
-        <p:nvSpPr>
-          <p:cNvPr id="3" name="Subtitle 2"/>
+          </a:p>
+        </p:txBody>
+      </p:sp>
+      <p:sp>
+        <p:nvSpPr>
+          <p:cNvPr id="3" name="Subtitle 2">
+            <a:extLst>
+              <a:ext uri="{FF2B5EF4-FFF2-40B4-BE49-F238E27FC236}">
+                <a16:creationId xmlns:a16="http://schemas.microsoft.com/office/drawing/2014/main" id="{F82F5398-A1F6-D293-C888-E904FC765359}"/>
+              </a:ext>
+            </a:extLst>
+          </p:cNvPr>
           <p:cNvSpPr>
             <a:spLocks noGrp="1"/>
           </p:cNvSpPr>
@@ -165,8 +180,8 @@
         </p:nvSpPr>
         <p:spPr>
           <a:xfrm>
-            <a:off x="1371600" y="3886200"/>
-            <a:ext cx="6400800" cy="1752600"/>
+            <a:off x="1524000" y="3602038"/>
+            <a:ext cx="9144000" cy="1655762"/>
           </a:xfrm>
         </p:spPr>
         <p:txBody>
@@ -174,122 +189,73 @@
           <a:lstStyle>
             <a:lvl1pPr marL="0" indent="0" algn="ctr">
               <a:buNone/>
-              <a:defRPr>
-                <a:solidFill>
-                  <a:schemeClr val="tx1">
-                    <a:tint val="75000"/>
-                  </a:schemeClr>
-                </a:solidFill>
-              </a:defRPr>
+              <a:defRPr sz="2400"/>
             </a:lvl1pPr>
             <a:lvl2pPr marL="457200" indent="0" algn="ctr">
               <a:buNone/>
-              <a:defRPr>
-                <a:solidFill>
-                  <a:schemeClr val="tx1">
-                    <a:tint val="75000"/>
-                  </a:schemeClr>
-                </a:solidFill>
-              </a:defRPr>
+              <a:defRPr sz="2000"/>
             </a:lvl2pPr>
             <a:lvl3pPr marL="914400" indent="0" algn="ctr">
               <a:buNone/>
-              <a:defRPr>
-                <a:solidFill>
-                  <a:schemeClr val="tx1">
-                    <a:tint val="75000"/>
-                  </a:schemeClr>
-                </a:solidFill>
-              </a:defRPr>
+              <a:defRPr sz="1800"/>
             </a:lvl3pPr>
             <a:lvl4pPr marL="1371600" indent="0" algn="ctr">
               <a:buNone/>
-              <a:defRPr>
-                <a:solidFill>
-                  <a:schemeClr val="tx1">
-                    <a:tint val="75000"/>
-                  </a:schemeClr>
-                </a:solidFill>
-              </a:defRPr>
+              <a:defRPr sz="1600"/>
             </a:lvl4pPr>
             <a:lvl5pPr marL="1828800" indent="0" algn="ctr">
               <a:buNone/>
-              <a:defRPr>
-                <a:solidFill>
-                  <a:schemeClr val="tx1">
-                    <a:tint val="75000"/>
-                  </a:schemeClr>
-                </a:solidFill>
-              </a:defRPr>
+              <a:defRPr sz="1600"/>
             </a:lvl5pPr>
             <a:lvl6pPr marL="2286000" indent="0" algn="ctr">
               <a:buNone/>
-              <a:defRPr>
-                <a:solidFill>
-                  <a:schemeClr val="tx1">
-                    <a:tint val="75000"/>
-                  </a:schemeClr>
-                </a:solidFill>
-              </a:defRPr>
+              <a:defRPr sz="1600"/>
             </a:lvl6pPr>
             <a:lvl7pPr marL="2743200" indent="0" algn="ctr">
               <a:buNone/>
-              <a:defRPr>
-                <a:solidFill>
-                  <a:schemeClr val="tx1">
-                    <a:tint val="75000"/>
-                  </a:schemeClr>
-                </a:solidFill>
-              </a:defRPr>
+              <a:defRPr sz="1600"/>
             </a:lvl7pPr>
             <a:lvl8pPr marL="3200400" indent="0" algn="ctr">
               <a:buNone/>
-              <a:defRPr>
-                <a:solidFill>
-                  <a:schemeClr val="tx1">
-                    <a:tint val="75000"/>
-                  </a:schemeClr>
-                </a:solidFill>
-              </a:defRPr>
+              <a:defRPr sz="1600"/>
             </a:lvl8pPr>
             <a:lvl9pPr marL="3657600" indent="0" algn="ctr">
               <a:buNone/>
-              <a:defRPr>
-                <a:solidFill>
-                  <a:schemeClr val="tx1">
-                    <a:tint val="75000"/>
-                  </a:schemeClr>
-                </a:solidFill>
-              </a:defRPr>
+              <a:defRPr sz="1600"/>
             </a:lvl9pPr>
           </a:lstStyle>
           <a:p>
             <a:r>
+              <a:rPr lang="en-US"/>
+              <a:t>Click to edit Master subtitle style</a:t>
+            </a:r>
+          </a:p>
+        </p:txBody>
+      </p:sp>
+      <p:sp>
+        <p:nvSpPr>
+          <p:cNvPr id="4" name="Date Placeholder 3">
+            <a:extLst>
+              <a:ext uri="{FF2B5EF4-FFF2-40B4-BE49-F238E27FC236}">
+                <a16:creationId xmlns:a16="http://schemas.microsoft.com/office/drawing/2014/main" id="{DA8D0BE3-F0B7-6EED-08C1-F145EE1A218D}"/>
+              </a:ext>
+            </a:extLst>
+          </p:cNvPr>
+          <p:cNvSpPr>
+            <a:spLocks noGrp="1"/>
+          </p:cNvSpPr>
+          <p:nvPr>
+            <p:ph type="dt" sz="half" idx="10"/>
+          </p:nvPr>
+        </p:nvSpPr>
+        <p:spPr/>
+        <p:txBody>
+          <a:bodyPr/>
+          <a:lstStyle/>
+          <a:p>
+            <a:fld id="{889D59F5-FA95-4135-83D3-8A6DCE68FA7F}" type="datetimeFigureOut">
               <a:rPr lang="en-US" smtClean="0"/>
-              <a:t>Click to edit Master subtitle style</a:t>
-            </a:r>
-            <a:endParaRPr lang="en-US"/>
-          </a:p>
-        </p:txBody>
-      </p:sp>
-      <p:sp>
-        <p:nvSpPr>
-          <p:cNvPr id="4" name="Date Placeholder 3"/>
-          <p:cNvSpPr>
-            <a:spLocks noGrp="1"/>
-          </p:cNvSpPr>
-          <p:nvPr>
-            <p:ph type="dt" sz="half" idx="10"/>
-          </p:nvPr>
-        </p:nvSpPr>
-        <p:spPr/>
-        <p:txBody>
-          <a:bodyPr/>
-          <a:lstStyle/>
-          <a:p>
-            <a:fld id="{5BCAD085-E8A6-8845-BD4E-CB4CCA059FC4}" type="datetimeFigureOut">
-              <a:rPr lang="en-US" smtClean="0"/>
-              <a:t>1/27/13</a:t>
+              <a:t>1/10/2023</a:t>
             </a:fld>
             <a:endParaRPr lang="en-US"/>
           </a:p>
@@ -297,7 +263,13 @@
       </p:sp>
       <p:sp>
         <p:nvSpPr>
-          <p:cNvPr id="5" name="Footer Placeholder 4"/>
+          <p:cNvPr id="5" name="Footer Placeholder 4">
+            <a:extLst>
+              <a:ext uri="{FF2B5EF4-FFF2-40B4-BE49-F238E27FC236}">
+                <a16:creationId xmlns:a16="http://schemas.microsoft.com/office/drawing/2014/main" id="{EABA583E-5582-4D4A-5745-37566616098A}"/>
+              </a:ext>
+            </a:extLst>
+          </p:cNvPr>
           <p:cNvSpPr>
             <a:spLocks noGrp="1"/>
           </p:cNvSpPr>
@@ -316,7 +288,13 @@
       </p:sp>
       <p:sp>
         <p:nvSpPr>
-          <p:cNvPr id="6" name="Slide Number Placeholder 5"/>
+          <p:cNvPr id="6" name="Slide Number Placeholder 5">
+            <a:extLst>
+              <a:ext uri="{FF2B5EF4-FFF2-40B4-BE49-F238E27FC236}">
+                <a16:creationId xmlns:a16="http://schemas.microsoft.com/office/drawing/2014/main" id="{77F7E06C-4E0E-E48F-E04F-B49F3D4A581D}"/>
+              </a:ext>
+            </a:extLst>
+          </p:cNvPr>
           <p:cNvSpPr>
             <a:spLocks noGrp="1"/>
           </p:cNvSpPr>
@@ -329,7 +307,7 @@
           <a:bodyPr/>
           <a:lstStyle/>
           <a:p>
-            <a:fld id="{C1FF6DA9-008F-8B48-92A6-B652298478BF}" type="slidenum">
+            <a:fld id="{5D3F3E41-C438-4411-9D33-2B0DE7F3C933}" type="slidenum">
               <a:rPr lang="en-US" smtClean="0"/>
               <a:t>‹#›</a:t>
             </a:fld>
@@ -340,7 +318,7 @@
     </p:spTree>
     <p:extLst>
       <p:ext uri="{BB962C8B-B14F-4D97-AF65-F5344CB8AC3E}">
-        <p14:creationId xmlns:p14="http://schemas.microsoft.com/office/powerpoint/2010/main" val="3168075583"/>
+        <p14:creationId xmlns:p14="http://schemas.microsoft.com/office/powerpoint/2010/main" val="76442660"/>
       </p:ext>
     </p:extLst>
   </p:cSld>
@@ -369,7 +347,13 @@
       </p:grpSpPr>
       <p:sp>
         <p:nvSpPr>
-          <p:cNvPr id="2" name="Title 1"/>
+          <p:cNvPr id="2" name="Title 1">
+            <a:extLst>
+              <a:ext uri="{FF2B5EF4-FFF2-40B4-BE49-F238E27FC236}">
+                <a16:creationId xmlns:a16="http://schemas.microsoft.com/office/drawing/2014/main" id="{C4ABA757-A767-8928-93DC-187F06C86CAA}"/>
+              </a:ext>
+            </a:extLst>
+          </p:cNvPr>
           <p:cNvSpPr>
             <a:spLocks noGrp="1"/>
           </p:cNvSpPr>
@@ -383,83 +367,93 @@
           <a:lstStyle/>
           <a:p>
             <a:r>
+              <a:rPr lang="en-US"/>
+              <a:t>Click to edit Master title style</a:t>
+            </a:r>
+          </a:p>
+        </p:txBody>
+      </p:sp>
+      <p:sp>
+        <p:nvSpPr>
+          <p:cNvPr id="3" name="Vertical Text Placeholder 2">
+            <a:extLst>
+              <a:ext uri="{FF2B5EF4-FFF2-40B4-BE49-F238E27FC236}">
+                <a16:creationId xmlns:a16="http://schemas.microsoft.com/office/drawing/2014/main" id="{8CDEEE51-C8E1-4502-45E9-EDA3D742D555}"/>
+              </a:ext>
+            </a:extLst>
+          </p:cNvPr>
+          <p:cNvSpPr>
+            <a:spLocks noGrp="1"/>
+          </p:cNvSpPr>
+          <p:nvPr>
+            <p:ph type="body" orient="vert" idx="1"/>
+          </p:nvPr>
+        </p:nvSpPr>
+        <p:spPr/>
+        <p:txBody>
+          <a:bodyPr vert="eaVert"/>
+          <a:lstStyle/>
+          <a:p>
+            <a:pPr lvl="0"/>
+            <a:r>
+              <a:rPr lang="en-US"/>
+              <a:t>Click to edit Master text styles</a:t>
+            </a:r>
+          </a:p>
+          <a:p>
+            <a:pPr lvl="1"/>
+            <a:r>
+              <a:rPr lang="en-US"/>
+              <a:t>Second level</a:t>
+            </a:r>
+          </a:p>
+          <a:p>
+            <a:pPr lvl="2"/>
+            <a:r>
+              <a:rPr lang="en-US"/>
+              <a:t>Third level</a:t>
+            </a:r>
+          </a:p>
+          <a:p>
+            <a:pPr lvl="3"/>
+            <a:r>
+              <a:rPr lang="en-US"/>
+              <a:t>Fourth level</a:t>
+            </a:r>
+          </a:p>
+          <a:p>
+            <a:pPr lvl="4"/>
+            <a:r>
+              <a:rPr lang="en-US"/>
+              <a:t>Fifth level</a:t>
+            </a:r>
+          </a:p>
+        </p:txBody>
+      </p:sp>
+      <p:sp>
+        <p:nvSpPr>
+          <p:cNvPr id="4" name="Date Placeholder 3">
+            <a:extLst>
+              <a:ext uri="{FF2B5EF4-FFF2-40B4-BE49-F238E27FC236}">
+                <a16:creationId xmlns:a16="http://schemas.microsoft.com/office/drawing/2014/main" id="{6104E5C7-7C61-25AE-D5BA-035D17E8DE14}"/>
+              </a:ext>
+            </a:extLst>
+          </p:cNvPr>
+          <p:cNvSpPr>
+            <a:spLocks noGrp="1"/>
+          </p:cNvSpPr>
+          <p:nvPr>
+            <p:ph type="dt" sz="half" idx="10"/>
+          </p:nvPr>
+        </p:nvSpPr>
+        <p:spPr/>
+        <p:txBody>
+          <a:bodyPr/>
+          <a:lstStyle/>
+          <a:p>
+            <a:fld id="{889D59F5-FA95-4135-83D3-8A6DCE68FA7F}" type="datetimeFigureOut">
               <a:rPr lang="en-US" smtClean="0"/>
-              <a:t>Click to edit Master title style</a:t>
-            </a:r>
-            <a:endParaRPr lang="en-US"/>
-          </a:p>
-        </p:txBody>
-      </p:sp>
-      <p:sp>
-        <p:nvSpPr>
-          <p:cNvPr id="3" name="Vertical Text Placeholder 2"/>
-          <p:cNvSpPr>
-            <a:spLocks noGrp="1"/>
-          </p:cNvSpPr>
-          <p:nvPr>
-            <p:ph type="body" orient="vert" idx="1"/>
-          </p:nvPr>
-        </p:nvSpPr>
-        <p:spPr/>
-        <p:txBody>
-          <a:bodyPr vert="eaVert"/>
-          <a:lstStyle/>
-          <a:p>
-            <a:pPr lvl="0"/>
-            <a:r>
-              <a:rPr lang="en-US" smtClean="0"/>
-              <a:t>Click to edit Master text styles</a:t>
-            </a:r>
-          </a:p>
-          <a:p>
-            <a:pPr lvl="1"/>
-            <a:r>
-              <a:rPr lang="en-US" smtClean="0"/>
-              <a:t>Second level</a:t>
-            </a:r>
-          </a:p>
-          <a:p>
-            <a:pPr lvl="2"/>
-            <a:r>
-              <a:rPr lang="en-US" smtClean="0"/>
-              <a:t>Third level</a:t>
-            </a:r>
-          </a:p>
-          <a:p>
-            <a:pPr lvl="3"/>
-            <a:r>
-              <a:rPr lang="en-US" smtClean="0"/>
-              <a:t>Fourth level</a:t>
-            </a:r>
-          </a:p>
-          <a:p>
-            <a:pPr lvl="4"/>
-            <a:r>
-              <a:rPr lang="en-US" smtClean="0"/>
-              <a:t>Fifth level</a:t>
-            </a:r>
-            <a:endParaRPr lang="en-US"/>
-          </a:p>
-        </p:txBody>
-      </p:sp>
-      <p:sp>
-        <p:nvSpPr>
-          <p:cNvPr id="4" name="Date Placeholder 3"/>
-          <p:cNvSpPr>
-            <a:spLocks noGrp="1"/>
-          </p:cNvSpPr>
-          <p:nvPr>
-            <p:ph type="dt" sz="half" idx="10"/>
-          </p:nvPr>
-        </p:nvSpPr>
-        <p:spPr/>
-        <p:txBody>
-          <a:bodyPr/>
-          <a:lstStyle/>
-          <a:p>
-            <a:fld id="{5BCAD085-E8A6-8845-BD4E-CB4CCA059FC4}" type="datetimeFigureOut">
-              <a:rPr lang="en-US" smtClean="0"/>
-              <a:t>1/27/13</a:t>
+              <a:t>1/10/2023</a:t>
             </a:fld>
             <a:endParaRPr lang="en-US"/>
           </a:p>
@@ -467,7 +461,13 @@
       </p:sp>
       <p:sp>
         <p:nvSpPr>
-          <p:cNvPr id="5" name="Footer Placeholder 4"/>
+          <p:cNvPr id="5" name="Footer Placeholder 4">
+            <a:extLst>
+              <a:ext uri="{FF2B5EF4-FFF2-40B4-BE49-F238E27FC236}">
+                <a16:creationId xmlns:a16="http://schemas.microsoft.com/office/drawing/2014/main" id="{9241575D-E921-579D-6FA6-161FE680B887}"/>
+              </a:ext>
+            </a:extLst>
+          </p:cNvPr>
           <p:cNvSpPr>
             <a:spLocks noGrp="1"/>
           </p:cNvSpPr>
@@ -486,7 +486,13 @@
       </p:sp>
       <p:sp>
         <p:nvSpPr>
-          <p:cNvPr id="6" name="Slide Number Placeholder 5"/>
+          <p:cNvPr id="6" name="Slide Number Placeholder 5">
+            <a:extLst>
+              <a:ext uri="{FF2B5EF4-FFF2-40B4-BE49-F238E27FC236}">
+                <a16:creationId xmlns:a16="http://schemas.microsoft.com/office/drawing/2014/main" id="{46403A09-769C-5B05-F9C2-82D310C3F1AE}"/>
+              </a:ext>
+            </a:extLst>
+          </p:cNvPr>
           <p:cNvSpPr>
             <a:spLocks noGrp="1"/>
           </p:cNvSpPr>
@@ -499,7 +505,7 @@
           <a:bodyPr/>
           <a:lstStyle/>
           <a:p>
-            <a:fld id="{C1FF6DA9-008F-8B48-92A6-B652298478BF}" type="slidenum">
+            <a:fld id="{5D3F3E41-C438-4411-9D33-2B0DE7F3C933}" type="slidenum">
               <a:rPr lang="en-US" smtClean="0"/>
               <a:t>‹#›</a:t>
             </a:fld>
@@ -510,7 +516,7 @@
     </p:spTree>
     <p:extLst>
       <p:ext uri="{BB962C8B-B14F-4D97-AF65-F5344CB8AC3E}">
-        <p14:creationId xmlns:p14="http://schemas.microsoft.com/office/powerpoint/2010/main" val="2910927964"/>
+        <p14:creationId xmlns:p14="http://schemas.microsoft.com/office/powerpoint/2010/main" val="4056098859"/>
       </p:ext>
     </p:extLst>
   </p:cSld>
@@ -539,7 +545,13 @@
       </p:grpSpPr>
       <p:sp>
         <p:nvSpPr>
-          <p:cNvPr id="2" name="Vertical Title 1"/>
+          <p:cNvPr id="2" name="Vertical Title 1">
+            <a:extLst>
+              <a:ext uri="{FF2B5EF4-FFF2-40B4-BE49-F238E27FC236}">
+                <a16:creationId xmlns:a16="http://schemas.microsoft.com/office/drawing/2014/main" id="{BAF77FAB-75B8-C9A7-690C-C5D85C1B27AF}"/>
+              </a:ext>
+            </a:extLst>
+          </p:cNvPr>
           <p:cNvSpPr>
             <a:spLocks noGrp="1"/>
           </p:cNvSpPr>
@@ -549,8 +561,8 @@
         </p:nvSpPr>
         <p:spPr>
           <a:xfrm>
-            <a:off x="6629400" y="274638"/>
-            <a:ext cx="2057400" cy="5851525"/>
+            <a:off x="8724900" y="365125"/>
+            <a:ext cx="2628900" cy="5811838"/>
           </a:xfrm>
         </p:spPr>
         <p:txBody>
@@ -558,16 +570,21 @@
           <a:lstStyle/>
           <a:p>
             <a:r>
-              <a:rPr lang="en-US" smtClean="0"/>
+              <a:rPr lang="en-US"/>
               <a:t>Click to edit Master title style</a:t>
             </a:r>
-            <a:endParaRPr lang="en-US"/>
-          </a:p>
-        </p:txBody>
-      </p:sp>
-      <p:sp>
-        <p:nvSpPr>
-          <p:cNvPr id="3" name="Vertical Text Placeholder 2"/>
+          </a:p>
+        </p:txBody>
+      </p:sp>
+      <p:sp>
+        <p:nvSpPr>
+          <p:cNvPr id="3" name="Vertical Text Placeholder 2">
+            <a:extLst>
+              <a:ext uri="{FF2B5EF4-FFF2-40B4-BE49-F238E27FC236}">
+                <a16:creationId xmlns:a16="http://schemas.microsoft.com/office/drawing/2014/main" id="{DE9259B7-8B31-8656-DB84-FC41F668B89A}"/>
+              </a:ext>
+            </a:extLst>
+          </p:cNvPr>
           <p:cNvSpPr>
             <a:spLocks noGrp="1"/>
           </p:cNvSpPr>
@@ -577,8 +594,8 @@
         </p:nvSpPr>
         <p:spPr>
           <a:xfrm>
-            <a:off x="457200" y="274638"/>
-            <a:ext cx="6019800" cy="5851525"/>
+            <a:off x="838200" y="365125"/>
+            <a:ext cx="7734300" cy="5811838"/>
           </a:xfrm>
         </p:spPr>
         <p:txBody>
@@ -587,59 +604,64 @@
           <a:p>
             <a:pPr lvl="0"/>
             <a:r>
+              <a:rPr lang="en-US"/>
+              <a:t>Click to edit Master text styles</a:t>
+            </a:r>
+          </a:p>
+          <a:p>
+            <a:pPr lvl="1"/>
+            <a:r>
+              <a:rPr lang="en-US"/>
+              <a:t>Second level</a:t>
+            </a:r>
+          </a:p>
+          <a:p>
+            <a:pPr lvl="2"/>
+            <a:r>
+              <a:rPr lang="en-US"/>
+              <a:t>Third level</a:t>
+            </a:r>
+          </a:p>
+          <a:p>
+            <a:pPr lvl="3"/>
+            <a:r>
+              <a:rPr lang="en-US"/>
+              <a:t>Fourth level</a:t>
+            </a:r>
+          </a:p>
+          <a:p>
+            <a:pPr lvl="4"/>
+            <a:r>
+              <a:rPr lang="en-US"/>
+              <a:t>Fifth level</a:t>
+            </a:r>
+          </a:p>
+        </p:txBody>
+      </p:sp>
+      <p:sp>
+        <p:nvSpPr>
+          <p:cNvPr id="4" name="Date Placeholder 3">
+            <a:extLst>
+              <a:ext uri="{FF2B5EF4-FFF2-40B4-BE49-F238E27FC236}">
+                <a16:creationId xmlns:a16="http://schemas.microsoft.com/office/drawing/2014/main" id="{E08C8044-13E8-2D82-410B-81F2C059C7C1}"/>
+              </a:ext>
+            </a:extLst>
+          </p:cNvPr>
+          <p:cNvSpPr>
+            <a:spLocks noGrp="1"/>
+          </p:cNvSpPr>
+          <p:nvPr>
+            <p:ph type="dt" sz="half" idx="10"/>
+          </p:nvPr>
+        </p:nvSpPr>
+        <p:spPr/>
+        <p:txBody>
+          <a:bodyPr/>
+          <a:lstStyle/>
+          <a:p>
+            <a:fld id="{889D59F5-FA95-4135-83D3-8A6DCE68FA7F}" type="datetimeFigureOut">
               <a:rPr lang="en-US" smtClean="0"/>
-              <a:t>Click to edit Master text styles</a:t>
-            </a:r>
-          </a:p>
-          <a:p>
-            <a:pPr lvl="1"/>
-            <a:r>
-              <a:rPr lang="en-US" smtClean="0"/>
-              <a:t>Second level</a:t>
-            </a:r>
-          </a:p>
-          <a:p>
-            <a:pPr lvl="2"/>
-            <a:r>
-              <a:rPr lang="en-US" smtClean="0"/>
-              <a:t>Third level</a:t>
-            </a:r>
-          </a:p>
-          <a:p>
-            <a:pPr lvl="3"/>
-            <a:r>
-              <a:rPr lang="en-US" smtClean="0"/>
-              <a:t>Fourth level</a:t>
-            </a:r>
-          </a:p>
-          <a:p>
-            <a:pPr lvl="4"/>
-            <a:r>
-              <a:rPr lang="en-US" smtClean="0"/>
-              <a:t>Fifth level</a:t>
-            </a:r>
-            <a:endParaRPr lang="en-US"/>
-          </a:p>
-        </p:txBody>
-      </p:sp>
-      <p:sp>
-        <p:nvSpPr>
-          <p:cNvPr id="4" name="Date Placeholder 3"/>
-          <p:cNvSpPr>
-            <a:spLocks noGrp="1"/>
-          </p:cNvSpPr>
-          <p:nvPr>
-            <p:ph type="dt" sz="half" idx="10"/>
-          </p:nvPr>
-        </p:nvSpPr>
-        <p:spPr/>
-        <p:txBody>
-          <a:bodyPr/>
-          <a:lstStyle/>
-          <a:p>
-            <a:fld id="{5BCAD085-E8A6-8845-BD4E-CB4CCA059FC4}" type="datetimeFigureOut">
-              <a:rPr lang="en-US" smtClean="0"/>
-              <a:t>1/27/13</a:t>
+              <a:t>1/10/2023</a:t>
             </a:fld>
             <a:endParaRPr lang="en-US"/>
           </a:p>
@@ -647,7 +669,13 @@
       </p:sp>
       <p:sp>
         <p:nvSpPr>
-          <p:cNvPr id="5" name="Footer Placeholder 4"/>
+          <p:cNvPr id="5" name="Footer Placeholder 4">
+            <a:extLst>
+              <a:ext uri="{FF2B5EF4-FFF2-40B4-BE49-F238E27FC236}">
+                <a16:creationId xmlns:a16="http://schemas.microsoft.com/office/drawing/2014/main" id="{0E85EAC6-D419-6ECD-F4A5-2A18332C4B0E}"/>
+              </a:ext>
+            </a:extLst>
+          </p:cNvPr>
           <p:cNvSpPr>
             <a:spLocks noGrp="1"/>
           </p:cNvSpPr>
@@ -666,7 +694,13 @@
       </p:sp>
       <p:sp>
         <p:nvSpPr>
-          <p:cNvPr id="6" name="Slide Number Placeholder 5"/>
+          <p:cNvPr id="6" name="Slide Number Placeholder 5">
+            <a:extLst>
+              <a:ext uri="{FF2B5EF4-FFF2-40B4-BE49-F238E27FC236}">
+                <a16:creationId xmlns:a16="http://schemas.microsoft.com/office/drawing/2014/main" id="{CC7CFA67-F983-55D0-C76A-2D7A0D0C42B7}"/>
+              </a:ext>
+            </a:extLst>
+          </p:cNvPr>
           <p:cNvSpPr>
             <a:spLocks noGrp="1"/>
           </p:cNvSpPr>
@@ -679,7 +713,7 @@
           <a:bodyPr/>
           <a:lstStyle/>
           <a:p>
-            <a:fld id="{C1FF6DA9-008F-8B48-92A6-B652298478BF}" type="slidenum">
+            <a:fld id="{5D3F3E41-C438-4411-9D33-2B0DE7F3C933}" type="slidenum">
               <a:rPr lang="en-US" smtClean="0"/>
               <a:t>‹#›</a:t>
             </a:fld>
@@ -690,7 +724,7 @@
     </p:spTree>
     <p:extLst>
       <p:ext uri="{BB962C8B-B14F-4D97-AF65-F5344CB8AC3E}">
-        <p14:creationId xmlns:p14="http://schemas.microsoft.com/office/powerpoint/2010/main" val="3612223792"/>
+        <p14:creationId xmlns:p14="http://schemas.microsoft.com/office/powerpoint/2010/main" val="2949619087"/>
       </p:ext>
     </p:extLst>
   </p:cSld>
@@ -719,7 +753,13 @@
       </p:grpSpPr>
       <p:sp>
         <p:nvSpPr>
-          <p:cNvPr id="2" name="Title 1"/>
+          <p:cNvPr id="2" name="Title 1">
+            <a:extLst>
+              <a:ext uri="{FF2B5EF4-FFF2-40B4-BE49-F238E27FC236}">
+                <a16:creationId xmlns:a16="http://schemas.microsoft.com/office/drawing/2014/main" id="{C5BD391E-F61D-FB93-2B91-627E6BEC7670}"/>
+              </a:ext>
+            </a:extLst>
+          </p:cNvPr>
           <p:cNvSpPr>
             <a:spLocks noGrp="1"/>
           </p:cNvSpPr>
@@ -733,83 +773,93 @@
           <a:lstStyle/>
           <a:p>
             <a:r>
+              <a:rPr lang="en-US"/>
+              <a:t>Click to edit Master title style</a:t>
+            </a:r>
+          </a:p>
+        </p:txBody>
+      </p:sp>
+      <p:sp>
+        <p:nvSpPr>
+          <p:cNvPr id="3" name="Content Placeholder 2">
+            <a:extLst>
+              <a:ext uri="{FF2B5EF4-FFF2-40B4-BE49-F238E27FC236}">
+                <a16:creationId xmlns:a16="http://schemas.microsoft.com/office/drawing/2014/main" id="{CA8B2FE6-1C8E-6FDE-CB62-24551520C180}"/>
+              </a:ext>
+            </a:extLst>
+          </p:cNvPr>
+          <p:cNvSpPr>
+            <a:spLocks noGrp="1"/>
+          </p:cNvSpPr>
+          <p:nvPr>
+            <p:ph idx="1"/>
+          </p:nvPr>
+        </p:nvSpPr>
+        <p:spPr/>
+        <p:txBody>
+          <a:bodyPr/>
+          <a:lstStyle/>
+          <a:p>
+            <a:pPr lvl="0"/>
+            <a:r>
+              <a:rPr lang="en-US"/>
+              <a:t>Click to edit Master text styles</a:t>
+            </a:r>
+          </a:p>
+          <a:p>
+            <a:pPr lvl="1"/>
+            <a:r>
+              <a:rPr lang="en-US"/>
+              <a:t>Second level</a:t>
+            </a:r>
+          </a:p>
+          <a:p>
+            <a:pPr lvl="2"/>
+            <a:r>
+              <a:rPr lang="en-US"/>
+              <a:t>Third level</a:t>
+            </a:r>
+          </a:p>
+          <a:p>
+            <a:pPr lvl="3"/>
+            <a:r>
+              <a:rPr lang="en-US"/>
+              <a:t>Fourth level</a:t>
+            </a:r>
+          </a:p>
+          <a:p>
+            <a:pPr lvl="4"/>
+            <a:r>
+              <a:rPr lang="en-US"/>
+              <a:t>Fifth level</a:t>
+            </a:r>
+          </a:p>
+        </p:txBody>
+      </p:sp>
+      <p:sp>
+        <p:nvSpPr>
+          <p:cNvPr id="4" name="Date Placeholder 3">
+            <a:extLst>
+              <a:ext uri="{FF2B5EF4-FFF2-40B4-BE49-F238E27FC236}">
+                <a16:creationId xmlns:a16="http://schemas.microsoft.com/office/drawing/2014/main" id="{0B161513-1FFF-4460-827C-D7BB407DA6B7}"/>
+              </a:ext>
+            </a:extLst>
+          </p:cNvPr>
+          <p:cNvSpPr>
+            <a:spLocks noGrp="1"/>
+          </p:cNvSpPr>
+          <p:nvPr>
+            <p:ph type="dt" sz="half" idx="10"/>
+          </p:nvPr>
+        </p:nvSpPr>
+        <p:spPr/>
+        <p:txBody>
+          <a:bodyPr/>
+          <a:lstStyle/>
+          <a:p>
+            <a:fld id="{889D59F5-FA95-4135-83D3-8A6DCE68FA7F}" type="datetimeFigureOut">
               <a:rPr lang="en-US" smtClean="0"/>
-              <a:t>Click to edit Master title style</a:t>
-            </a:r>
-            <a:endParaRPr lang="en-US"/>
-          </a:p>
-        </p:txBody>
-      </p:sp>
-      <p:sp>
-        <p:nvSpPr>
-          <p:cNvPr id="3" name="Content Placeholder 2"/>
-          <p:cNvSpPr>
-            <a:spLocks noGrp="1"/>
-          </p:cNvSpPr>
-          <p:nvPr>
-            <p:ph idx="1"/>
-          </p:nvPr>
-        </p:nvSpPr>
-        <p:spPr/>
-        <p:txBody>
-          <a:bodyPr/>
-          <a:lstStyle/>
-          <a:p>
-            <a:pPr lvl="0"/>
-            <a:r>
-              <a:rPr lang="en-US" smtClean="0"/>
-              <a:t>Click to edit Master text styles</a:t>
-            </a:r>
-          </a:p>
-          <a:p>
-            <a:pPr lvl="1"/>
-            <a:r>
-              <a:rPr lang="en-US" smtClean="0"/>
-              <a:t>Second level</a:t>
-            </a:r>
-          </a:p>
-          <a:p>
-            <a:pPr lvl="2"/>
-            <a:r>
-              <a:rPr lang="en-US" smtClean="0"/>
-              <a:t>Third level</a:t>
-            </a:r>
-          </a:p>
-          <a:p>
-            <a:pPr lvl="3"/>
-            <a:r>
-              <a:rPr lang="en-US" smtClean="0"/>
-              <a:t>Fourth level</a:t>
-            </a:r>
-          </a:p>
-          <a:p>
-            <a:pPr lvl="4"/>
-            <a:r>
-              <a:rPr lang="en-US" smtClean="0"/>
-              <a:t>Fifth level</a:t>
-            </a:r>
-            <a:endParaRPr lang="en-US"/>
-          </a:p>
-        </p:txBody>
-      </p:sp>
-      <p:sp>
-        <p:nvSpPr>
-          <p:cNvPr id="4" name="Date Placeholder 3"/>
-          <p:cNvSpPr>
-            <a:spLocks noGrp="1"/>
-          </p:cNvSpPr>
-          <p:nvPr>
-            <p:ph type="dt" sz="half" idx="10"/>
-          </p:nvPr>
-        </p:nvSpPr>
-        <p:spPr/>
-        <p:txBody>
-          <a:bodyPr/>
-          <a:lstStyle/>
-          <a:p>
-            <a:fld id="{5BCAD085-E8A6-8845-BD4E-CB4CCA059FC4}" type="datetimeFigureOut">
-              <a:rPr lang="en-US" smtClean="0"/>
-              <a:t>1/27/13</a:t>
+              <a:t>1/10/2023</a:t>
             </a:fld>
             <a:endParaRPr lang="en-US"/>
           </a:p>
@@ -817,7 +867,13 @@
       </p:sp>
       <p:sp>
         <p:nvSpPr>
-          <p:cNvPr id="5" name="Footer Placeholder 4"/>
+          <p:cNvPr id="5" name="Footer Placeholder 4">
+            <a:extLst>
+              <a:ext uri="{FF2B5EF4-FFF2-40B4-BE49-F238E27FC236}">
+                <a16:creationId xmlns:a16="http://schemas.microsoft.com/office/drawing/2014/main" id="{7BD15451-802E-91CC-5908-179F333E3D65}"/>
+              </a:ext>
+            </a:extLst>
+          </p:cNvPr>
           <p:cNvSpPr>
             <a:spLocks noGrp="1"/>
           </p:cNvSpPr>
@@ -836,7 +892,13 @@
       </p:sp>
       <p:sp>
         <p:nvSpPr>
-          <p:cNvPr id="6" name="Slide Number Placeholder 5"/>
+          <p:cNvPr id="6" name="Slide Number Placeholder 5">
+            <a:extLst>
+              <a:ext uri="{FF2B5EF4-FFF2-40B4-BE49-F238E27FC236}">
+                <a16:creationId xmlns:a16="http://schemas.microsoft.com/office/drawing/2014/main" id="{405B95B9-CFBC-7DAC-D8EA-693A924CEEF6}"/>
+              </a:ext>
+            </a:extLst>
+          </p:cNvPr>
           <p:cNvSpPr>
             <a:spLocks noGrp="1"/>
           </p:cNvSpPr>
@@ -849,7 +911,7 @@
           <a:bodyPr/>
           <a:lstStyle/>
           <a:p>
-            <a:fld id="{C1FF6DA9-008F-8B48-92A6-B652298478BF}" type="slidenum">
+            <a:fld id="{5D3F3E41-C438-4411-9D33-2B0DE7F3C933}" type="slidenum">
               <a:rPr lang="en-US" smtClean="0"/>
               <a:t>‹#›</a:t>
             </a:fld>
@@ -860,7 +922,7 @@
     </p:spTree>
     <p:extLst>
       <p:ext uri="{BB962C8B-B14F-4D97-AF65-F5344CB8AC3E}">
-        <p14:creationId xmlns:p14="http://schemas.microsoft.com/office/powerpoint/2010/main" val="2614314258"/>
+        <p14:creationId xmlns:p14="http://schemas.microsoft.com/office/powerpoint/2010/main" val="3687157179"/>
       </p:ext>
     </p:extLst>
   </p:cSld>
@@ -889,7 +951,13 @@
       </p:grpSpPr>
       <p:sp>
         <p:nvSpPr>
-          <p:cNvPr id="2" name="Title 1"/>
+          <p:cNvPr id="2" name="Title 1">
+            <a:extLst>
+              <a:ext uri="{FF2B5EF4-FFF2-40B4-BE49-F238E27FC236}">
+                <a16:creationId xmlns:a16="http://schemas.microsoft.com/office/drawing/2014/main" id="{74B86242-0670-5076-01A2-ED6D7F47745D}"/>
+              </a:ext>
+            </a:extLst>
+          </p:cNvPr>
           <p:cNvSpPr>
             <a:spLocks noGrp="1"/>
           </p:cNvSpPr>
@@ -899,29 +967,34 @@
         </p:nvSpPr>
         <p:spPr>
           <a:xfrm>
-            <a:off x="722313" y="4406900"/>
-            <a:ext cx="7772400" cy="1362075"/>
+            <a:off x="831850" y="1709738"/>
+            <a:ext cx="10515600" cy="2852737"/>
           </a:xfrm>
         </p:spPr>
         <p:txBody>
-          <a:bodyPr anchor="t"/>
+          <a:bodyPr anchor="b"/>
           <a:lstStyle>
-            <a:lvl1pPr algn="l">
-              <a:defRPr sz="4000" b="1" cap="all"/>
+            <a:lvl1pPr>
+              <a:defRPr sz="6000"/>
             </a:lvl1pPr>
           </a:lstStyle>
           <a:p>
             <a:r>
-              <a:rPr lang="en-US" smtClean="0"/>
+              <a:rPr lang="en-US"/>
               <a:t>Click to edit Master title style</a:t>
             </a:r>
-            <a:endParaRPr lang="en-US"/>
-          </a:p>
-        </p:txBody>
-      </p:sp>
-      <p:sp>
-        <p:nvSpPr>
-          <p:cNvPr id="3" name="Text Placeholder 2"/>
+          </a:p>
+        </p:txBody>
+      </p:sp>
+      <p:sp>
+        <p:nvSpPr>
+          <p:cNvPr id="3" name="Text Placeholder 2">
+            <a:extLst>
+              <a:ext uri="{FF2B5EF4-FFF2-40B4-BE49-F238E27FC236}">
+                <a16:creationId xmlns:a16="http://schemas.microsoft.com/office/drawing/2014/main" id="{1DC141F9-9C7D-473A-D53A-95B52903807F}"/>
+              </a:ext>
+            </a:extLst>
+          </p:cNvPr>
           <p:cNvSpPr>
             <a:spLocks noGrp="1"/>
           </p:cNvSpPr>
@@ -931,16 +1004,16 @@
         </p:nvSpPr>
         <p:spPr>
           <a:xfrm>
-            <a:off x="722313" y="2906713"/>
-            <a:ext cx="7772400" cy="1500187"/>
+            <a:off x="831850" y="4589463"/>
+            <a:ext cx="10515600" cy="1500187"/>
           </a:xfrm>
         </p:spPr>
         <p:txBody>
-          <a:bodyPr anchor="b"/>
+          <a:bodyPr/>
           <a:lstStyle>
             <a:lvl1pPr marL="0" indent="0">
               <a:buNone/>
-              <a:defRPr sz="2000">
+              <a:defRPr sz="2400">
                 <a:solidFill>
                   <a:schemeClr val="tx1">
                     <a:tint val="75000"/>
@@ -950,7 +1023,7 @@
             </a:lvl1pPr>
             <a:lvl2pPr marL="457200" indent="0">
               <a:buNone/>
-              <a:defRPr sz="1800">
+              <a:defRPr sz="2000">
                 <a:solidFill>
                   <a:schemeClr val="tx1">
                     <a:tint val="75000"/>
@@ -960,7 +1033,7 @@
             </a:lvl2pPr>
             <a:lvl3pPr marL="914400" indent="0">
               <a:buNone/>
-              <a:defRPr sz="1600">
+              <a:defRPr sz="1800">
                 <a:solidFill>
                   <a:schemeClr val="tx1">
                     <a:tint val="75000"/>
@@ -970,7 +1043,7 @@
             </a:lvl3pPr>
             <a:lvl4pPr marL="1371600" indent="0">
               <a:buNone/>
-              <a:defRPr sz="1400">
+              <a:defRPr sz="1600">
                 <a:solidFill>
                   <a:schemeClr val="tx1">
                     <a:tint val="75000"/>
@@ -980,7 +1053,7 @@
             </a:lvl4pPr>
             <a:lvl5pPr marL="1828800" indent="0">
               <a:buNone/>
-              <a:defRPr sz="1400">
+              <a:defRPr sz="1600">
                 <a:solidFill>
                   <a:schemeClr val="tx1">
                     <a:tint val="75000"/>
@@ -990,7 +1063,7 @@
             </a:lvl5pPr>
             <a:lvl6pPr marL="2286000" indent="0">
               <a:buNone/>
-              <a:defRPr sz="1400">
+              <a:defRPr sz="1600">
                 <a:solidFill>
                   <a:schemeClr val="tx1">
                     <a:tint val="75000"/>
@@ -1000,7 +1073,7 @@
             </a:lvl6pPr>
             <a:lvl7pPr marL="2743200" indent="0">
               <a:buNone/>
-              <a:defRPr sz="1400">
+              <a:defRPr sz="1600">
                 <a:solidFill>
                   <a:schemeClr val="tx1">
                     <a:tint val="75000"/>
@@ -1010,7 +1083,7 @@
             </a:lvl7pPr>
             <a:lvl8pPr marL="3200400" indent="0">
               <a:buNone/>
-              <a:defRPr sz="1400">
+              <a:defRPr sz="1600">
                 <a:solidFill>
                   <a:schemeClr val="tx1">
                     <a:tint val="75000"/>
@@ -1020,7 +1093,7 @@
             </a:lvl8pPr>
             <a:lvl9pPr marL="3657600" indent="0">
               <a:buNone/>
-              <a:defRPr sz="1400">
+              <a:defRPr sz="1600">
                 <a:solidFill>
                   <a:schemeClr val="tx1">
                     <a:tint val="75000"/>
@@ -1032,30 +1105,36 @@
           <a:p>
             <a:pPr lvl="0"/>
             <a:r>
+              <a:rPr lang="en-US"/>
+              <a:t>Click to edit Master text styles</a:t>
+            </a:r>
+          </a:p>
+        </p:txBody>
+      </p:sp>
+      <p:sp>
+        <p:nvSpPr>
+          <p:cNvPr id="4" name="Date Placeholder 3">
+            <a:extLst>
+              <a:ext uri="{FF2B5EF4-FFF2-40B4-BE49-F238E27FC236}">
+                <a16:creationId xmlns:a16="http://schemas.microsoft.com/office/drawing/2014/main" id="{BA0584D4-5C07-BF11-04E5-83D3D48DA0BE}"/>
+              </a:ext>
+            </a:extLst>
+          </p:cNvPr>
+          <p:cNvSpPr>
+            <a:spLocks noGrp="1"/>
+          </p:cNvSpPr>
+          <p:nvPr>
+            <p:ph type="dt" sz="half" idx="10"/>
+          </p:nvPr>
+        </p:nvSpPr>
+        <p:spPr/>
+        <p:txBody>
+          <a:bodyPr/>
+          <a:lstStyle/>
+          <a:p>
+            <a:fld id="{889D59F5-FA95-4135-83D3-8A6DCE68FA7F}" type="datetimeFigureOut">
               <a:rPr lang="en-US" smtClean="0"/>
-              <a:t>Click to edit Master text styles</a:t>
-            </a:r>
-          </a:p>
-        </p:txBody>
-      </p:sp>
-      <p:sp>
-        <p:nvSpPr>
-          <p:cNvPr id="4" name="Date Placeholder 3"/>
-          <p:cNvSpPr>
-            <a:spLocks noGrp="1"/>
-          </p:cNvSpPr>
-          <p:nvPr>
-            <p:ph type="dt" sz="half" idx="10"/>
-          </p:nvPr>
-        </p:nvSpPr>
-        <p:spPr/>
-        <p:txBody>
-          <a:bodyPr/>
-          <a:lstStyle/>
-          <a:p>
-            <a:fld id="{5BCAD085-E8A6-8845-BD4E-CB4CCA059FC4}" type="datetimeFigureOut">
-              <a:rPr lang="en-US" smtClean="0"/>
-              <a:t>1/27/13</a:t>
+              <a:t>1/10/2023</a:t>
             </a:fld>
             <a:endParaRPr lang="en-US"/>
           </a:p>
@@ -1063,7 +1142,13 @@
       </p:sp>
       <p:sp>
         <p:nvSpPr>
-          <p:cNvPr id="5" name="Footer Placeholder 4"/>
+          <p:cNvPr id="5" name="Footer Placeholder 4">
+            <a:extLst>
+              <a:ext uri="{FF2B5EF4-FFF2-40B4-BE49-F238E27FC236}">
+                <a16:creationId xmlns:a16="http://schemas.microsoft.com/office/drawing/2014/main" id="{4E06C864-2D31-AA4F-CDA3-C50397B08E77}"/>
+              </a:ext>
+            </a:extLst>
+          </p:cNvPr>
           <p:cNvSpPr>
             <a:spLocks noGrp="1"/>
           </p:cNvSpPr>
@@ -1082,7 +1167,13 @@
       </p:sp>
       <p:sp>
         <p:nvSpPr>
-          <p:cNvPr id="6" name="Slide Number Placeholder 5"/>
+          <p:cNvPr id="6" name="Slide Number Placeholder 5">
+            <a:extLst>
+              <a:ext uri="{FF2B5EF4-FFF2-40B4-BE49-F238E27FC236}">
+                <a16:creationId xmlns:a16="http://schemas.microsoft.com/office/drawing/2014/main" id="{DC3FC667-176B-1305-AC0C-BA9CAA62E9CD}"/>
+              </a:ext>
+            </a:extLst>
+          </p:cNvPr>
           <p:cNvSpPr>
             <a:spLocks noGrp="1"/>
           </p:cNvSpPr>
@@ -1095,7 +1186,7 @@
           <a:bodyPr/>
           <a:lstStyle/>
           <a:p>
-            <a:fld id="{C1FF6DA9-008F-8B48-92A6-B652298478BF}" type="slidenum">
+            <a:fld id="{5D3F3E41-C438-4411-9D33-2B0DE7F3C933}" type="slidenum">
               <a:rPr lang="en-US" smtClean="0"/>
               <a:t>‹#›</a:t>
             </a:fld>
@@ -1106,7 +1197,7 @@
     </p:spTree>
     <p:extLst>
       <p:ext uri="{BB962C8B-B14F-4D97-AF65-F5344CB8AC3E}">
-        <p14:creationId xmlns:p14="http://schemas.microsoft.com/office/powerpoint/2010/main" val="960648375"/>
+        <p14:creationId xmlns:p14="http://schemas.microsoft.com/office/powerpoint/2010/main" val="2535896924"/>
       </p:ext>
     </p:extLst>
   </p:cSld>
@@ -1135,7 +1226,13 @@
       </p:grpSpPr>
       <p:sp>
         <p:nvSpPr>
-          <p:cNvPr id="2" name="Title 1"/>
+          <p:cNvPr id="2" name="Title 1">
+            <a:extLst>
+              <a:ext uri="{FF2B5EF4-FFF2-40B4-BE49-F238E27FC236}">
+                <a16:creationId xmlns:a16="http://schemas.microsoft.com/office/drawing/2014/main" id="{4DF8BA7B-C4D4-4D2E-9CC7-DAB45A8DCDCC}"/>
+              </a:ext>
+            </a:extLst>
+          </p:cNvPr>
           <p:cNvSpPr>
             <a:spLocks noGrp="1"/>
           </p:cNvSpPr>
@@ -1149,16 +1246,21 @@
           <a:lstStyle/>
           <a:p>
             <a:r>
-              <a:rPr lang="en-US" smtClean="0"/>
+              <a:rPr lang="en-US"/>
               <a:t>Click to edit Master title style</a:t>
             </a:r>
-            <a:endParaRPr lang="en-US"/>
-          </a:p>
-        </p:txBody>
-      </p:sp>
-      <p:sp>
-        <p:nvSpPr>
-          <p:cNvPr id="3" name="Content Placeholder 2"/>
+          </a:p>
+        </p:txBody>
+      </p:sp>
+      <p:sp>
+        <p:nvSpPr>
+          <p:cNvPr id="3" name="Content Placeholder 2">
+            <a:extLst>
+              <a:ext uri="{FF2B5EF4-FFF2-40B4-BE49-F238E27FC236}">
+                <a16:creationId xmlns:a16="http://schemas.microsoft.com/office/drawing/2014/main" id="{802C8709-6FF2-2BD0-4792-2D5352A466C2}"/>
+              </a:ext>
+            </a:extLst>
+          </p:cNvPr>
           <p:cNvSpPr>
             <a:spLocks noGrp="1"/>
           </p:cNvSpPr>
@@ -1168,82 +1270,59 @@
         </p:nvSpPr>
         <p:spPr>
           <a:xfrm>
-            <a:off x="457200" y="1600200"/>
-            <a:ext cx="4038600" cy="4525963"/>
+            <a:off x="838200" y="1825625"/>
+            <a:ext cx="5181600" cy="4351338"/>
           </a:xfrm>
         </p:spPr>
         <p:txBody>
           <a:bodyPr/>
-          <a:lstStyle>
-            <a:lvl1pPr>
-              <a:defRPr sz="2800"/>
-            </a:lvl1pPr>
-            <a:lvl2pPr>
-              <a:defRPr sz="2400"/>
-            </a:lvl2pPr>
-            <a:lvl3pPr>
-              <a:defRPr sz="2000"/>
-            </a:lvl3pPr>
-            <a:lvl4pPr>
-              <a:defRPr sz="1800"/>
-            </a:lvl4pPr>
-            <a:lvl5pPr>
-              <a:defRPr sz="1800"/>
-            </a:lvl5pPr>
-            <a:lvl6pPr>
-              <a:defRPr sz="1800"/>
-            </a:lvl6pPr>
-            <a:lvl7pPr>
-              <a:defRPr sz="1800"/>
-            </a:lvl7pPr>
-            <a:lvl8pPr>
-              <a:defRPr sz="1800"/>
-            </a:lvl8pPr>
-            <a:lvl9pPr>
-              <a:defRPr sz="1800"/>
-            </a:lvl9pPr>
-          </a:lstStyle>
+          <a:lstStyle/>
           <a:p>
             <a:pPr lvl="0"/>
             <a:r>
-              <a:rPr lang="en-US" smtClean="0"/>
+              <a:rPr lang="en-US"/>
               <a:t>Click to edit Master text styles</a:t>
             </a:r>
           </a:p>
           <a:p>
             <a:pPr lvl="1"/>
             <a:r>
-              <a:rPr lang="en-US" smtClean="0"/>
+              <a:rPr lang="en-US"/>
               <a:t>Second level</a:t>
             </a:r>
           </a:p>
           <a:p>
             <a:pPr lvl="2"/>
             <a:r>
-              <a:rPr lang="en-US" smtClean="0"/>
+              <a:rPr lang="en-US"/>
               <a:t>Third level</a:t>
             </a:r>
           </a:p>
           <a:p>
             <a:pPr lvl="3"/>
             <a:r>
-              <a:rPr lang="en-US" smtClean="0"/>
+              <a:rPr lang="en-US"/>
               <a:t>Fourth level</a:t>
             </a:r>
           </a:p>
           <a:p>
             <a:pPr lvl="4"/>
             <a:r>
-              <a:rPr lang="en-US" smtClean="0"/>
+              <a:rPr lang="en-US"/>
               <a:t>Fifth level</a:t>
             </a:r>
-            <a:endParaRPr lang="en-US"/>
-          </a:p>
-        </p:txBody>
-      </p:sp>
-      <p:sp>
-        <p:nvSpPr>
-          <p:cNvPr id="4" name="Content Placeholder 3"/>
+          </a:p>
+        </p:txBody>
+      </p:sp>
+      <p:sp>
+        <p:nvSpPr>
+          <p:cNvPr id="4" name="Content Placeholder 3">
+            <a:extLst>
+              <a:ext uri="{FF2B5EF4-FFF2-40B4-BE49-F238E27FC236}">
+                <a16:creationId xmlns:a16="http://schemas.microsoft.com/office/drawing/2014/main" id="{464C03EA-AF49-6093-818B-25476A28C2AB}"/>
+              </a:ext>
+            </a:extLst>
+          </p:cNvPr>
           <p:cNvSpPr>
             <a:spLocks noGrp="1"/>
           </p:cNvSpPr>
@@ -1253,97 +1332,74 @@
         </p:nvSpPr>
         <p:spPr>
           <a:xfrm>
-            <a:off x="4648200" y="1600200"/>
-            <a:ext cx="4038600" cy="4525963"/>
+            <a:off x="6172200" y="1825625"/>
+            <a:ext cx="5181600" cy="4351338"/>
           </a:xfrm>
         </p:spPr>
         <p:txBody>
           <a:bodyPr/>
-          <a:lstStyle>
-            <a:lvl1pPr>
-              <a:defRPr sz="2800"/>
-            </a:lvl1pPr>
-            <a:lvl2pPr>
-              <a:defRPr sz="2400"/>
-            </a:lvl2pPr>
-            <a:lvl3pPr>
-              <a:defRPr sz="2000"/>
-            </a:lvl3pPr>
-            <a:lvl4pPr>
-              <a:defRPr sz="1800"/>
-            </a:lvl4pPr>
-            <a:lvl5pPr>
-              <a:defRPr sz="1800"/>
-            </a:lvl5pPr>
-            <a:lvl6pPr>
-              <a:defRPr sz="1800"/>
-            </a:lvl6pPr>
-            <a:lvl7pPr>
-              <a:defRPr sz="1800"/>
-            </a:lvl7pPr>
-            <a:lvl8pPr>
-              <a:defRPr sz="1800"/>
-            </a:lvl8pPr>
-            <a:lvl9pPr>
-              <a:defRPr sz="1800"/>
-            </a:lvl9pPr>
-          </a:lstStyle>
+          <a:lstStyle/>
           <a:p>
             <a:pPr lvl="0"/>
             <a:r>
+              <a:rPr lang="en-US"/>
+              <a:t>Click to edit Master text styles</a:t>
+            </a:r>
+          </a:p>
+          <a:p>
+            <a:pPr lvl="1"/>
+            <a:r>
+              <a:rPr lang="en-US"/>
+              <a:t>Second level</a:t>
+            </a:r>
+          </a:p>
+          <a:p>
+            <a:pPr lvl="2"/>
+            <a:r>
+              <a:rPr lang="en-US"/>
+              <a:t>Third level</a:t>
+            </a:r>
+          </a:p>
+          <a:p>
+            <a:pPr lvl="3"/>
+            <a:r>
+              <a:rPr lang="en-US"/>
+              <a:t>Fourth level</a:t>
+            </a:r>
+          </a:p>
+          <a:p>
+            <a:pPr lvl="4"/>
+            <a:r>
+              <a:rPr lang="en-US"/>
+              <a:t>Fifth level</a:t>
+            </a:r>
+          </a:p>
+        </p:txBody>
+      </p:sp>
+      <p:sp>
+        <p:nvSpPr>
+          <p:cNvPr id="5" name="Date Placeholder 4">
+            <a:extLst>
+              <a:ext uri="{FF2B5EF4-FFF2-40B4-BE49-F238E27FC236}">
+                <a16:creationId xmlns:a16="http://schemas.microsoft.com/office/drawing/2014/main" id="{1CACECEB-BB88-E1DE-4EB7-57B6C2F0CCD5}"/>
+              </a:ext>
+            </a:extLst>
+          </p:cNvPr>
+          <p:cNvSpPr>
+            <a:spLocks noGrp="1"/>
+          </p:cNvSpPr>
+          <p:nvPr>
+            <p:ph type="dt" sz="half" idx="10"/>
+          </p:nvPr>
+        </p:nvSpPr>
+        <p:spPr/>
+        <p:txBody>
+          <a:bodyPr/>
+          <a:lstStyle/>
+          <a:p>
+            <a:fld id="{889D59F5-FA95-4135-83D3-8A6DCE68FA7F}" type="datetimeFigureOut">
               <a:rPr lang="en-US" smtClean="0"/>
-              <a:t>Click to edit Master text styles</a:t>
-            </a:r>
-          </a:p>
-          <a:p>
-            <a:pPr lvl="1"/>
-            <a:r>
-              <a:rPr lang="en-US" smtClean="0"/>
-              <a:t>Second level</a:t>
-            </a:r>
-          </a:p>
-          <a:p>
-            <a:pPr lvl="2"/>
-            <a:r>
-              <a:rPr lang="en-US" smtClean="0"/>
-              <a:t>Third level</a:t>
-            </a:r>
-          </a:p>
-          <a:p>
-            <a:pPr lvl="3"/>
-            <a:r>
-              <a:rPr lang="en-US" smtClean="0"/>
-              <a:t>Fourth level</a:t>
-            </a:r>
-          </a:p>
-          <a:p>
-            <a:pPr lvl="4"/>
-            <a:r>
-              <a:rPr lang="en-US" smtClean="0"/>
-              <a:t>Fifth level</a:t>
-            </a:r>
-            <a:endParaRPr lang="en-US"/>
-          </a:p>
-        </p:txBody>
-      </p:sp>
-      <p:sp>
-        <p:nvSpPr>
-          <p:cNvPr id="5" name="Date Placeholder 4"/>
-          <p:cNvSpPr>
-            <a:spLocks noGrp="1"/>
-          </p:cNvSpPr>
-          <p:nvPr>
-            <p:ph type="dt" sz="half" idx="10"/>
-          </p:nvPr>
-        </p:nvSpPr>
-        <p:spPr/>
-        <p:txBody>
-          <a:bodyPr/>
-          <a:lstStyle/>
-          <a:p>
-            <a:fld id="{5BCAD085-E8A6-8845-BD4E-CB4CCA059FC4}" type="datetimeFigureOut">
-              <a:rPr lang="en-US" smtClean="0"/>
-              <a:t>1/27/13</a:t>
+              <a:t>1/10/2023</a:t>
             </a:fld>
             <a:endParaRPr lang="en-US"/>
           </a:p>
@@ -1351,7 +1407,13 @@
       </p:sp>
       <p:sp>
         <p:nvSpPr>
-          <p:cNvPr id="6" name="Footer Placeholder 5"/>
+          <p:cNvPr id="6" name="Footer Placeholder 5">
+            <a:extLst>
+              <a:ext uri="{FF2B5EF4-FFF2-40B4-BE49-F238E27FC236}">
+                <a16:creationId xmlns:a16="http://schemas.microsoft.com/office/drawing/2014/main" id="{EC9A00CB-F9E1-9C8D-D58C-1B8D66216FB5}"/>
+              </a:ext>
+            </a:extLst>
+          </p:cNvPr>
           <p:cNvSpPr>
             <a:spLocks noGrp="1"/>
           </p:cNvSpPr>
@@ -1370,7 +1432,13 @@
       </p:sp>
       <p:sp>
         <p:nvSpPr>
-          <p:cNvPr id="7" name="Slide Number Placeholder 6"/>
+          <p:cNvPr id="7" name="Slide Number Placeholder 6">
+            <a:extLst>
+              <a:ext uri="{FF2B5EF4-FFF2-40B4-BE49-F238E27FC236}">
+                <a16:creationId xmlns:a16="http://schemas.microsoft.com/office/drawing/2014/main" id="{7BD00FBA-FF73-373D-78F3-337E06515326}"/>
+              </a:ext>
+            </a:extLst>
+          </p:cNvPr>
           <p:cNvSpPr>
             <a:spLocks noGrp="1"/>
           </p:cNvSpPr>
@@ -1383,7 +1451,7 @@
           <a:bodyPr/>
           <a:lstStyle/>
           <a:p>
-            <a:fld id="{C1FF6DA9-008F-8B48-92A6-B652298478BF}" type="slidenum">
+            <a:fld id="{5D3F3E41-C438-4411-9D33-2B0DE7F3C933}" type="slidenum">
               <a:rPr lang="en-US" smtClean="0"/>
               <a:t>‹#›</a:t>
             </a:fld>
@@ -1394,7 +1462,7 @@
     </p:spTree>
     <p:extLst>
       <p:ext uri="{BB962C8B-B14F-4D97-AF65-F5344CB8AC3E}">
-        <p14:creationId xmlns:p14="http://schemas.microsoft.com/office/powerpoint/2010/main" val="2782244947"/>
+        <p14:creationId xmlns:p14="http://schemas.microsoft.com/office/powerpoint/2010/main" val="1472287310"/>
       </p:ext>
     </p:extLst>
   </p:cSld>
@@ -1423,45 +1491,57 @@
       </p:grpSpPr>
       <p:sp>
         <p:nvSpPr>
-          <p:cNvPr id="2" name="Title 1"/>
+          <p:cNvPr id="2" name="Title 1">
+            <a:extLst>
+              <a:ext uri="{FF2B5EF4-FFF2-40B4-BE49-F238E27FC236}">
+                <a16:creationId xmlns:a16="http://schemas.microsoft.com/office/drawing/2014/main" id="{C3C5A492-8E9B-AF1C-FCD6-B10571532474}"/>
+              </a:ext>
+            </a:extLst>
+          </p:cNvPr>
           <p:cNvSpPr>
             <a:spLocks noGrp="1"/>
           </p:cNvSpPr>
           <p:nvPr>
             <p:ph type="title"/>
-          </p:nvPr>
-        </p:nvSpPr>
-        <p:spPr/>
-        <p:txBody>
-          <a:bodyPr/>
-          <a:lstStyle>
-            <a:lvl1pPr>
-              <a:defRPr/>
-            </a:lvl1pPr>
-          </a:lstStyle>
-          <a:p>
-            <a:r>
-              <a:rPr lang="en-US" smtClean="0"/>
-              <a:t>Click to edit Master title style</a:t>
-            </a:r>
-            <a:endParaRPr lang="en-US"/>
-          </a:p>
-        </p:txBody>
-      </p:sp>
-      <p:sp>
-        <p:nvSpPr>
-          <p:cNvPr id="3" name="Text Placeholder 2"/>
-          <p:cNvSpPr>
-            <a:spLocks noGrp="1"/>
-          </p:cNvSpPr>
-          <p:nvPr>
-            <p:ph type="body" idx="1"/>
           </p:nvPr>
         </p:nvSpPr>
         <p:spPr>
           <a:xfrm>
-            <a:off x="457200" y="1535113"/>
-            <a:ext cx="4040188" cy="639762"/>
+            <a:off x="839788" y="365125"/>
+            <a:ext cx="10515600" cy="1325563"/>
+          </a:xfrm>
+        </p:spPr>
+        <p:txBody>
+          <a:bodyPr/>
+          <a:lstStyle/>
+          <a:p>
+            <a:r>
+              <a:rPr lang="en-US"/>
+              <a:t>Click to edit Master title style</a:t>
+            </a:r>
+          </a:p>
+        </p:txBody>
+      </p:sp>
+      <p:sp>
+        <p:nvSpPr>
+          <p:cNvPr id="3" name="Text Placeholder 2">
+            <a:extLst>
+              <a:ext uri="{FF2B5EF4-FFF2-40B4-BE49-F238E27FC236}">
+                <a16:creationId xmlns:a16="http://schemas.microsoft.com/office/drawing/2014/main" id="{CB4BF36C-D336-32E0-C7A8-46D61B9DB624}"/>
+              </a:ext>
+            </a:extLst>
+          </p:cNvPr>
+          <p:cNvSpPr>
+            <a:spLocks noGrp="1"/>
+          </p:cNvSpPr>
+          <p:nvPr>
+            <p:ph type="body" idx="1"/>
+          </p:nvPr>
+        </p:nvSpPr>
+        <p:spPr>
+          <a:xfrm>
+            <a:off x="839788" y="1681163"/>
+            <a:ext cx="5157787" cy="823912"/>
           </a:xfrm>
         </p:spPr>
         <p:txBody>
@@ -1507,7 +1587,7 @@
           <a:p>
             <a:pPr lvl="0"/>
             <a:r>
-              <a:rPr lang="en-US" smtClean="0"/>
+              <a:rPr lang="en-US"/>
               <a:t>Click to edit Master text styles</a:t>
             </a:r>
           </a:p>
@@ -1515,7 +1595,13 @@
       </p:sp>
       <p:sp>
         <p:nvSpPr>
-          <p:cNvPr id="4" name="Content Placeholder 3"/>
+          <p:cNvPr id="4" name="Content Placeholder 3">
+            <a:extLst>
+              <a:ext uri="{FF2B5EF4-FFF2-40B4-BE49-F238E27FC236}">
+                <a16:creationId xmlns:a16="http://schemas.microsoft.com/office/drawing/2014/main" id="{4B6D7E93-2542-07BC-F5D5-98A09F0E64DA}"/>
+              </a:ext>
+            </a:extLst>
+          </p:cNvPr>
           <p:cNvSpPr>
             <a:spLocks noGrp="1"/>
           </p:cNvSpPr>
@@ -1525,82 +1611,59 @@
         </p:nvSpPr>
         <p:spPr>
           <a:xfrm>
-            <a:off x="457200" y="2174875"/>
-            <a:ext cx="4040188" cy="3951288"/>
+            <a:off x="839788" y="2505075"/>
+            <a:ext cx="5157787" cy="3684588"/>
           </a:xfrm>
         </p:spPr>
         <p:txBody>
           <a:bodyPr/>
-          <a:lstStyle>
-            <a:lvl1pPr>
-              <a:defRPr sz="2400"/>
-            </a:lvl1pPr>
-            <a:lvl2pPr>
-              <a:defRPr sz="2000"/>
-            </a:lvl2pPr>
-            <a:lvl3pPr>
-              <a:defRPr sz="1800"/>
-            </a:lvl3pPr>
-            <a:lvl4pPr>
-              <a:defRPr sz="1600"/>
-            </a:lvl4pPr>
-            <a:lvl5pPr>
-              <a:defRPr sz="1600"/>
-            </a:lvl5pPr>
-            <a:lvl6pPr>
-              <a:defRPr sz="1600"/>
-            </a:lvl6pPr>
-            <a:lvl7pPr>
-              <a:defRPr sz="1600"/>
-            </a:lvl7pPr>
-            <a:lvl8pPr>
-              <a:defRPr sz="1600"/>
-            </a:lvl8pPr>
-            <a:lvl9pPr>
-              <a:defRPr sz="1600"/>
-            </a:lvl9pPr>
-          </a:lstStyle>
+          <a:lstStyle/>
           <a:p>
             <a:pPr lvl="0"/>
             <a:r>
-              <a:rPr lang="en-US" smtClean="0"/>
+              <a:rPr lang="en-US"/>
               <a:t>Click to edit Master text styles</a:t>
             </a:r>
           </a:p>
           <a:p>
             <a:pPr lvl="1"/>
             <a:r>
-              <a:rPr lang="en-US" smtClean="0"/>
+              <a:rPr lang="en-US"/>
               <a:t>Second level</a:t>
             </a:r>
           </a:p>
           <a:p>
             <a:pPr lvl="2"/>
             <a:r>
-              <a:rPr lang="en-US" smtClean="0"/>
+              <a:rPr lang="en-US"/>
               <a:t>Third level</a:t>
             </a:r>
           </a:p>
           <a:p>
             <a:pPr lvl="3"/>
             <a:r>
-              <a:rPr lang="en-US" smtClean="0"/>
+              <a:rPr lang="en-US"/>
               <a:t>Fourth level</a:t>
             </a:r>
           </a:p>
           <a:p>
             <a:pPr lvl="4"/>
             <a:r>
-              <a:rPr lang="en-US" smtClean="0"/>
+              <a:rPr lang="en-US"/>
               <a:t>Fifth level</a:t>
             </a:r>
-            <a:endParaRPr lang="en-US"/>
-          </a:p>
-        </p:txBody>
-      </p:sp>
-      <p:sp>
-        <p:nvSpPr>
-          <p:cNvPr id="5" name="Text Placeholder 4"/>
+          </a:p>
+        </p:txBody>
+      </p:sp>
+      <p:sp>
+        <p:nvSpPr>
+          <p:cNvPr id="5" name="Text Placeholder 4">
+            <a:extLst>
+              <a:ext uri="{FF2B5EF4-FFF2-40B4-BE49-F238E27FC236}">
+                <a16:creationId xmlns:a16="http://schemas.microsoft.com/office/drawing/2014/main" id="{8DD21F39-48A6-BB15-06DE-DE89243F929B}"/>
+              </a:ext>
+            </a:extLst>
+          </p:cNvPr>
           <p:cNvSpPr>
             <a:spLocks noGrp="1"/>
           </p:cNvSpPr>
@@ -1610,8 +1673,8 @@
         </p:nvSpPr>
         <p:spPr>
           <a:xfrm>
-            <a:off x="4645025" y="1535113"/>
-            <a:ext cx="4041775" cy="639762"/>
+            <a:off x="6172200" y="1681163"/>
+            <a:ext cx="5183188" cy="823912"/>
           </a:xfrm>
         </p:spPr>
         <p:txBody>
@@ -1657,7 +1720,7 @@
           <a:p>
             <a:pPr lvl="0"/>
             <a:r>
-              <a:rPr lang="en-US" smtClean="0"/>
+              <a:rPr lang="en-US"/>
               <a:t>Click to edit Master text styles</a:t>
             </a:r>
           </a:p>
@@ -1665,7 +1728,13 @@
       </p:sp>
       <p:sp>
         <p:nvSpPr>
-          <p:cNvPr id="6" name="Content Placeholder 5"/>
+          <p:cNvPr id="6" name="Content Placeholder 5">
+            <a:extLst>
+              <a:ext uri="{FF2B5EF4-FFF2-40B4-BE49-F238E27FC236}">
+                <a16:creationId xmlns:a16="http://schemas.microsoft.com/office/drawing/2014/main" id="{7737F4AE-95CC-22A1-748F-E08C8CADC98C}"/>
+              </a:ext>
+            </a:extLst>
+          </p:cNvPr>
           <p:cNvSpPr>
             <a:spLocks noGrp="1"/>
           </p:cNvSpPr>
@@ -1675,97 +1744,74 @@
         </p:nvSpPr>
         <p:spPr>
           <a:xfrm>
-            <a:off x="4645025" y="2174875"/>
-            <a:ext cx="4041775" cy="3951288"/>
+            <a:off x="6172200" y="2505075"/>
+            <a:ext cx="5183188" cy="3684588"/>
           </a:xfrm>
         </p:spPr>
         <p:txBody>
           <a:bodyPr/>
-          <a:lstStyle>
-            <a:lvl1pPr>
-              <a:defRPr sz="2400"/>
-            </a:lvl1pPr>
-            <a:lvl2pPr>
-              <a:defRPr sz="2000"/>
-            </a:lvl2pPr>
-            <a:lvl3pPr>
-              <a:defRPr sz="1800"/>
-            </a:lvl3pPr>
-            <a:lvl4pPr>
-              <a:defRPr sz="1600"/>
-            </a:lvl4pPr>
-            <a:lvl5pPr>
-              <a:defRPr sz="1600"/>
-            </a:lvl5pPr>
-            <a:lvl6pPr>
-              <a:defRPr sz="1600"/>
-            </a:lvl6pPr>
-            <a:lvl7pPr>
-              <a:defRPr sz="1600"/>
-            </a:lvl7pPr>
-            <a:lvl8pPr>
-              <a:defRPr sz="1600"/>
-            </a:lvl8pPr>
-            <a:lvl9pPr>
-              <a:defRPr sz="1600"/>
-            </a:lvl9pPr>
-          </a:lstStyle>
+          <a:lstStyle/>
           <a:p>
             <a:pPr lvl="0"/>
             <a:r>
+              <a:rPr lang="en-US"/>
+              <a:t>Click to edit Master text styles</a:t>
+            </a:r>
+          </a:p>
+          <a:p>
+            <a:pPr lvl="1"/>
+            <a:r>
+              <a:rPr lang="en-US"/>
+              <a:t>Second level</a:t>
+            </a:r>
+          </a:p>
+          <a:p>
+            <a:pPr lvl="2"/>
+            <a:r>
+              <a:rPr lang="en-US"/>
+              <a:t>Third level</a:t>
+            </a:r>
+          </a:p>
+          <a:p>
+            <a:pPr lvl="3"/>
+            <a:r>
+              <a:rPr lang="en-US"/>
+              <a:t>Fourth level</a:t>
+            </a:r>
+          </a:p>
+          <a:p>
+            <a:pPr lvl="4"/>
+            <a:r>
+              <a:rPr lang="en-US"/>
+              <a:t>Fifth level</a:t>
+            </a:r>
+          </a:p>
+        </p:txBody>
+      </p:sp>
+      <p:sp>
+        <p:nvSpPr>
+          <p:cNvPr id="7" name="Date Placeholder 6">
+            <a:extLst>
+              <a:ext uri="{FF2B5EF4-FFF2-40B4-BE49-F238E27FC236}">
+                <a16:creationId xmlns:a16="http://schemas.microsoft.com/office/drawing/2014/main" id="{A4A3446B-9352-B310-6E9F-63A4CD8E2BE7}"/>
+              </a:ext>
+            </a:extLst>
+          </p:cNvPr>
+          <p:cNvSpPr>
+            <a:spLocks noGrp="1"/>
+          </p:cNvSpPr>
+          <p:nvPr>
+            <p:ph type="dt" sz="half" idx="10"/>
+          </p:nvPr>
+        </p:nvSpPr>
+        <p:spPr/>
+        <p:txBody>
+          <a:bodyPr/>
+          <a:lstStyle/>
+          <a:p>
+            <a:fld id="{889D59F5-FA95-4135-83D3-8A6DCE68FA7F}" type="datetimeFigureOut">
               <a:rPr lang="en-US" smtClean="0"/>
-              <a:t>Click to edit Master text styles</a:t>
-            </a:r>
-          </a:p>
-          <a:p>
-            <a:pPr lvl="1"/>
-            <a:r>
-              <a:rPr lang="en-US" smtClean="0"/>
-              <a:t>Second level</a:t>
-            </a:r>
-          </a:p>
-          <a:p>
-            <a:pPr lvl="2"/>
-            <a:r>
-              <a:rPr lang="en-US" smtClean="0"/>
-              <a:t>Third level</a:t>
-            </a:r>
-          </a:p>
-          <a:p>
-            <a:pPr lvl="3"/>
-            <a:r>
-              <a:rPr lang="en-US" smtClean="0"/>
-              <a:t>Fourth level</a:t>
-            </a:r>
-          </a:p>
-          <a:p>
-            <a:pPr lvl="4"/>
-            <a:r>
-              <a:rPr lang="en-US" smtClean="0"/>
-              <a:t>Fifth level</a:t>
-            </a:r>
-            <a:endParaRPr lang="en-US"/>
-          </a:p>
-        </p:txBody>
-      </p:sp>
-      <p:sp>
-        <p:nvSpPr>
-          <p:cNvPr id="7" name="Date Placeholder 6"/>
-          <p:cNvSpPr>
-            <a:spLocks noGrp="1"/>
-          </p:cNvSpPr>
-          <p:nvPr>
-            <p:ph type="dt" sz="half" idx="10"/>
-          </p:nvPr>
-        </p:nvSpPr>
-        <p:spPr/>
-        <p:txBody>
-          <a:bodyPr/>
-          <a:lstStyle/>
-          <a:p>
-            <a:fld id="{5BCAD085-E8A6-8845-BD4E-CB4CCA059FC4}" type="datetimeFigureOut">
-              <a:rPr lang="en-US" smtClean="0"/>
-              <a:t>1/27/13</a:t>
+              <a:t>1/10/2023</a:t>
             </a:fld>
             <a:endParaRPr lang="en-US"/>
           </a:p>
@@ -1773,7 +1819,13 @@
       </p:sp>
       <p:sp>
         <p:nvSpPr>
-          <p:cNvPr id="8" name="Footer Placeholder 7"/>
+          <p:cNvPr id="8" name="Footer Placeholder 7">
+            <a:extLst>
+              <a:ext uri="{FF2B5EF4-FFF2-40B4-BE49-F238E27FC236}">
+                <a16:creationId xmlns:a16="http://schemas.microsoft.com/office/drawing/2014/main" id="{9C27AA4D-0693-F8E4-011B-A0131140C577}"/>
+              </a:ext>
+            </a:extLst>
+          </p:cNvPr>
           <p:cNvSpPr>
             <a:spLocks noGrp="1"/>
           </p:cNvSpPr>
@@ -1792,7 +1844,13 @@
       </p:sp>
       <p:sp>
         <p:nvSpPr>
-          <p:cNvPr id="9" name="Slide Number Placeholder 8"/>
+          <p:cNvPr id="9" name="Slide Number Placeholder 8">
+            <a:extLst>
+              <a:ext uri="{FF2B5EF4-FFF2-40B4-BE49-F238E27FC236}">
+                <a16:creationId xmlns:a16="http://schemas.microsoft.com/office/drawing/2014/main" id="{0D0091E7-FCFB-7BA3-32B7-7648D323E57A}"/>
+              </a:ext>
+            </a:extLst>
+          </p:cNvPr>
           <p:cNvSpPr>
             <a:spLocks noGrp="1"/>
           </p:cNvSpPr>
@@ -1805,7 +1863,7 @@
           <a:bodyPr/>
           <a:lstStyle/>
           <a:p>
-            <a:fld id="{C1FF6DA9-008F-8B48-92A6-B652298478BF}" type="slidenum">
+            <a:fld id="{5D3F3E41-C438-4411-9D33-2B0DE7F3C933}" type="slidenum">
               <a:rPr lang="en-US" smtClean="0"/>
               <a:t>‹#›</a:t>
             </a:fld>
@@ -1816,7 +1874,7 @@
     </p:spTree>
     <p:extLst>
       <p:ext uri="{BB962C8B-B14F-4D97-AF65-F5344CB8AC3E}">
-        <p14:creationId xmlns:p14="http://schemas.microsoft.com/office/powerpoint/2010/main" val="990158736"/>
+        <p14:creationId xmlns:p14="http://schemas.microsoft.com/office/powerpoint/2010/main" val="550623554"/>
       </p:ext>
     </p:extLst>
   </p:cSld>
@@ -1845,7 +1903,13 @@
       </p:grpSpPr>
       <p:sp>
         <p:nvSpPr>
-          <p:cNvPr id="2" name="Title 1"/>
+          <p:cNvPr id="2" name="Title 1">
+            <a:extLst>
+              <a:ext uri="{FF2B5EF4-FFF2-40B4-BE49-F238E27FC236}">
+                <a16:creationId xmlns:a16="http://schemas.microsoft.com/office/drawing/2014/main" id="{85C80858-D5E8-BF1D-97AC-D0A6D25E949E}"/>
+              </a:ext>
+            </a:extLst>
+          </p:cNvPr>
           <p:cNvSpPr>
             <a:spLocks noGrp="1"/>
           </p:cNvSpPr>
@@ -1859,31 +1923,36 @@
           <a:lstStyle/>
           <a:p>
             <a:r>
+              <a:rPr lang="en-US"/>
+              <a:t>Click to edit Master title style</a:t>
+            </a:r>
+          </a:p>
+        </p:txBody>
+      </p:sp>
+      <p:sp>
+        <p:nvSpPr>
+          <p:cNvPr id="3" name="Date Placeholder 2">
+            <a:extLst>
+              <a:ext uri="{FF2B5EF4-FFF2-40B4-BE49-F238E27FC236}">
+                <a16:creationId xmlns:a16="http://schemas.microsoft.com/office/drawing/2014/main" id="{BCCD6519-F8F6-22C3-E301-F79966D4202C}"/>
+              </a:ext>
+            </a:extLst>
+          </p:cNvPr>
+          <p:cNvSpPr>
+            <a:spLocks noGrp="1"/>
+          </p:cNvSpPr>
+          <p:nvPr>
+            <p:ph type="dt" sz="half" idx="10"/>
+          </p:nvPr>
+        </p:nvSpPr>
+        <p:spPr/>
+        <p:txBody>
+          <a:bodyPr/>
+          <a:lstStyle/>
+          <a:p>
+            <a:fld id="{889D59F5-FA95-4135-83D3-8A6DCE68FA7F}" type="datetimeFigureOut">
               <a:rPr lang="en-US" smtClean="0"/>
-              <a:t>Click to edit Master title style</a:t>
-            </a:r>
-            <a:endParaRPr lang="en-US"/>
-          </a:p>
-        </p:txBody>
-      </p:sp>
-      <p:sp>
-        <p:nvSpPr>
-          <p:cNvPr id="3" name="Date Placeholder 2"/>
-          <p:cNvSpPr>
-            <a:spLocks noGrp="1"/>
-          </p:cNvSpPr>
-          <p:nvPr>
-            <p:ph type="dt" sz="half" idx="10"/>
-          </p:nvPr>
-        </p:nvSpPr>
-        <p:spPr/>
-        <p:txBody>
-          <a:bodyPr/>
-          <a:lstStyle/>
-          <a:p>
-            <a:fld id="{5BCAD085-E8A6-8845-BD4E-CB4CCA059FC4}" type="datetimeFigureOut">
-              <a:rPr lang="en-US" smtClean="0"/>
-              <a:t>1/27/13</a:t>
+              <a:t>1/10/2023</a:t>
             </a:fld>
             <a:endParaRPr lang="en-US"/>
           </a:p>
@@ -1891,7 +1960,13 @@
       </p:sp>
       <p:sp>
         <p:nvSpPr>
-          <p:cNvPr id="4" name="Footer Placeholder 3"/>
+          <p:cNvPr id="4" name="Footer Placeholder 3">
+            <a:extLst>
+              <a:ext uri="{FF2B5EF4-FFF2-40B4-BE49-F238E27FC236}">
+                <a16:creationId xmlns:a16="http://schemas.microsoft.com/office/drawing/2014/main" id="{697D1AB2-8D7B-1719-8F58-0528A90C48CE}"/>
+              </a:ext>
+            </a:extLst>
+          </p:cNvPr>
           <p:cNvSpPr>
             <a:spLocks noGrp="1"/>
           </p:cNvSpPr>
@@ -1910,7 +1985,13 @@
       </p:sp>
       <p:sp>
         <p:nvSpPr>
-          <p:cNvPr id="5" name="Slide Number Placeholder 4"/>
+          <p:cNvPr id="5" name="Slide Number Placeholder 4">
+            <a:extLst>
+              <a:ext uri="{FF2B5EF4-FFF2-40B4-BE49-F238E27FC236}">
+                <a16:creationId xmlns:a16="http://schemas.microsoft.com/office/drawing/2014/main" id="{80D33110-F75A-CA57-4791-0693D5741292}"/>
+              </a:ext>
+            </a:extLst>
+          </p:cNvPr>
           <p:cNvSpPr>
             <a:spLocks noGrp="1"/>
           </p:cNvSpPr>
@@ -1923,7 +2004,7 @@
           <a:bodyPr/>
           <a:lstStyle/>
           <a:p>
-            <a:fld id="{C1FF6DA9-008F-8B48-92A6-B652298478BF}" type="slidenum">
+            <a:fld id="{5D3F3E41-C438-4411-9D33-2B0DE7F3C933}" type="slidenum">
               <a:rPr lang="en-US" smtClean="0"/>
               <a:t>‹#›</a:t>
             </a:fld>
@@ -1934,7 +2015,7 @@
     </p:spTree>
     <p:extLst>
       <p:ext uri="{BB962C8B-B14F-4D97-AF65-F5344CB8AC3E}">
-        <p14:creationId xmlns:p14="http://schemas.microsoft.com/office/powerpoint/2010/main" val="727027711"/>
+        <p14:creationId xmlns:p14="http://schemas.microsoft.com/office/powerpoint/2010/main" val="3137065717"/>
       </p:ext>
     </p:extLst>
   </p:cSld>
@@ -1963,7 +2044,13 @@
       </p:grpSpPr>
       <p:sp>
         <p:nvSpPr>
-          <p:cNvPr id="2" name="Date Placeholder 1"/>
+          <p:cNvPr id="2" name="Date Placeholder 1">
+            <a:extLst>
+              <a:ext uri="{FF2B5EF4-FFF2-40B4-BE49-F238E27FC236}">
+                <a16:creationId xmlns:a16="http://schemas.microsoft.com/office/drawing/2014/main" id="{FB67B5B0-2D32-8BD0-428F-5F23EAECA4E7}"/>
+              </a:ext>
+            </a:extLst>
+          </p:cNvPr>
           <p:cNvSpPr>
             <a:spLocks noGrp="1"/>
           </p:cNvSpPr>
@@ -1976,9 +2063,9 @@
           <a:bodyPr/>
           <a:lstStyle/>
           <a:p>
-            <a:fld id="{5BCAD085-E8A6-8845-BD4E-CB4CCA059FC4}" type="datetimeFigureOut">
+            <a:fld id="{889D59F5-FA95-4135-83D3-8A6DCE68FA7F}" type="datetimeFigureOut">
               <a:rPr lang="en-US" smtClean="0"/>
-              <a:t>1/27/13</a:t>
+              <a:t>1/10/2023</a:t>
             </a:fld>
             <a:endParaRPr lang="en-US"/>
           </a:p>
@@ -1986,7 +2073,13 @@
       </p:sp>
       <p:sp>
         <p:nvSpPr>
-          <p:cNvPr id="3" name="Footer Placeholder 2"/>
+          <p:cNvPr id="3" name="Footer Placeholder 2">
+            <a:extLst>
+              <a:ext uri="{FF2B5EF4-FFF2-40B4-BE49-F238E27FC236}">
+                <a16:creationId xmlns:a16="http://schemas.microsoft.com/office/drawing/2014/main" id="{DF2267D4-BDC8-C0EF-9ED3-DCB4466AEDAA}"/>
+              </a:ext>
+            </a:extLst>
+          </p:cNvPr>
           <p:cNvSpPr>
             <a:spLocks noGrp="1"/>
           </p:cNvSpPr>
@@ -2005,7 +2098,13 @@
       </p:sp>
       <p:sp>
         <p:nvSpPr>
-          <p:cNvPr id="4" name="Slide Number Placeholder 3"/>
+          <p:cNvPr id="4" name="Slide Number Placeholder 3">
+            <a:extLst>
+              <a:ext uri="{FF2B5EF4-FFF2-40B4-BE49-F238E27FC236}">
+                <a16:creationId xmlns:a16="http://schemas.microsoft.com/office/drawing/2014/main" id="{04526AE9-453A-6D2F-ADBF-C734022E28AD}"/>
+              </a:ext>
+            </a:extLst>
+          </p:cNvPr>
           <p:cNvSpPr>
             <a:spLocks noGrp="1"/>
           </p:cNvSpPr>
@@ -2018,7 +2117,7 @@
           <a:bodyPr/>
           <a:lstStyle/>
           <a:p>
-            <a:fld id="{C1FF6DA9-008F-8B48-92A6-B652298478BF}" type="slidenum">
+            <a:fld id="{5D3F3E41-C438-4411-9D33-2B0DE7F3C933}" type="slidenum">
               <a:rPr lang="en-US" smtClean="0"/>
               <a:t>‹#›</a:t>
             </a:fld>
@@ -2029,7 +2128,7 @@
     </p:spTree>
     <p:extLst>
       <p:ext uri="{BB962C8B-B14F-4D97-AF65-F5344CB8AC3E}">
-        <p14:creationId xmlns:p14="http://schemas.microsoft.com/office/powerpoint/2010/main" val="1212999818"/>
+        <p14:creationId xmlns:p14="http://schemas.microsoft.com/office/powerpoint/2010/main" val="3819010897"/>
       </p:ext>
     </p:extLst>
   </p:cSld>
@@ -2058,7 +2157,13 @@
       </p:grpSpPr>
       <p:sp>
         <p:nvSpPr>
-          <p:cNvPr id="2" name="Title 1"/>
+          <p:cNvPr id="2" name="Title 1">
+            <a:extLst>
+              <a:ext uri="{FF2B5EF4-FFF2-40B4-BE49-F238E27FC236}">
+                <a16:creationId xmlns:a16="http://schemas.microsoft.com/office/drawing/2014/main" id="{13F66989-29E2-837D-B8D9-FD9F7ED4936D}"/>
+              </a:ext>
+            </a:extLst>
+          </p:cNvPr>
           <p:cNvSpPr>
             <a:spLocks noGrp="1"/>
           </p:cNvSpPr>
@@ -2068,29 +2173,34 @@
         </p:nvSpPr>
         <p:spPr>
           <a:xfrm>
-            <a:off x="457200" y="273050"/>
-            <a:ext cx="3008313" cy="1162050"/>
+            <a:off x="839788" y="457200"/>
+            <a:ext cx="3932237" cy="1600200"/>
           </a:xfrm>
         </p:spPr>
         <p:txBody>
           <a:bodyPr anchor="b"/>
           <a:lstStyle>
-            <a:lvl1pPr algn="l">
-              <a:defRPr sz="2000" b="1"/>
+            <a:lvl1pPr>
+              <a:defRPr sz="3200"/>
             </a:lvl1pPr>
           </a:lstStyle>
           <a:p>
             <a:r>
-              <a:rPr lang="en-US" smtClean="0"/>
+              <a:rPr lang="en-US"/>
               <a:t>Click to edit Master title style</a:t>
             </a:r>
-            <a:endParaRPr lang="en-US"/>
-          </a:p>
-        </p:txBody>
-      </p:sp>
-      <p:sp>
-        <p:nvSpPr>
-          <p:cNvPr id="3" name="Content Placeholder 2"/>
+          </a:p>
+        </p:txBody>
+      </p:sp>
+      <p:sp>
+        <p:nvSpPr>
+          <p:cNvPr id="3" name="Content Placeholder 2">
+            <a:extLst>
+              <a:ext uri="{FF2B5EF4-FFF2-40B4-BE49-F238E27FC236}">
+                <a16:creationId xmlns:a16="http://schemas.microsoft.com/office/drawing/2014/main" id="{9168A8DC-97E0-DEBE-5904-79662D8DE096}"/>
+              </a:ext>
+            </a:extLst>
+          </p:cNvPr>
           <p:cNvSpPr>
             <a:spLocks noGrp="1"/>
           </p:cNvSpPr>
@@ -2100,8 +2210,8 @@
         </p:nvSpPr>
         <p:spPr>
           <a:xfrm>
-            <a:off x="3575050" y="273050"/>
-            <a:ext cx="5111750" cy="5853113"/>
+            <a:off x="5183188" y="987425"/>
+            <a:ext cx="6172200" cy="4873625"/>
           </a:xfrm>
         </p:spPr>
         <p:txBody>
@@ -2138,44 +2248,49 @@
           <a:p>
             <a:pPr lvl="0"/>
             <a:r>
-              <a:rPr lang="en-US" smtClean="0"/>
+              <a:rPr lang="en-US"/>
               <a:t>Click to edit Master text styles</a:t>
             </a:r>
           </a:p>
           <a:p>
             <a:pPr lvl="1"/>
             <a:r>
-              <a:rPr lang="en-US" smtClean="0"/>
+              <a:rPr lang="en-US"/>
               <a:t>Second level</a:t>
             </a:r>
           </a:p>
           <a:p>
             <a:pPr lvl="2"/>
             <a:r>
-              <a:rPr lang="en-US" smtClean="0"/>
+              <a:rPr lang="en-US"/>
               <a:t>Third level</a:t>
             </a:r>
           </a:p>
           <a:p>
             <a:pPr lvl="3"/>
             <a:r>
-              <a:rPr lang="en-US" smtClean="0"/>
+              <a:rPr lang="en-US"/>
               <a:t>Fourth level</a:t>
             </a:r>
           </a:p>
           <a:p>
             <a:pPr lvl="4"/>
             <a:r>
-              <a:rPr lang="en-US" smtClean="0"/>
+              <a:rPr lang="en-US"/>
               <a:t>Fifth level</a:t>
             </a:r>
-            <a:endParaRPr lang="en-US"/>
-          </a:p>
-        </p:txBody>
-      </p:sp>
-      <p:sp>
-        <p:nvSpPr>
-          <p:cNvPr id="4" name="Text Placeholder 3"/>
+          </a:p>
+        </p:txBody>
+      </p:sp>
+      <p:sp>
+        <p:nvSpPr>
+          <p:cNvPr id="4" name="Text Placeholder 3">
+            <a:extLst>
+              <a:ext uri="{FF2B5EF4-FFF2-40B4-BE49-F238E27FC236}">
+                <a16:creationId xmlns:a16="http://schemas.microsoft.com/office/drawing/2014/main" id="{DEEA074C-04D0-FAC0-92FE-CF7B5C54F410}"/>
+              </a:ext>
+            </a:extLst>
+          </p:cNvPr>
           <p:cNvSpPr>
             <a:spLocks noGrp="1"/>
           </p:cNvSpPr>
@@ -2185,8 +2300,8 @@
         </p:nvSpPr>
         <p:spPr>
           <a:xfrm>
-            <a:off x="457200" y="1435100"/>
-            <a:ext cx="3008313" cy="4691063"/>
+            <a:off x="839788" y="2057400"/>
+            <a:ext cx="3932237" cy="3811588"/>
           </a:xfrm>
         </p:spPr>
         <p:txBody>
@@ -2194,68 +2309,74 @@
           <a:lstStyle>
             <a:lvl1pPr marL="0" indent="0">
               <a:buNone/>
-              <a:defRPr sz="1400"/>
+              <a:defRPr sz="1600"/>
             </a:lvl1pPr>
             <a:lvl2pPr marL="457200" indent="0">
               <a:buNone/>
-              <a:defRPr sz="1200"/>
+              <a:defRPr sz="1400"/>
             </a:lvl2pPr>
             <a:lvl3pPr marL="914400" indent="0">
               <a:buNone/>
-              <a:defRPr sz="1000"/>
+              <a:defRPr sz="1200"/>
             </a:lvl3pPr>
             <a:lvl4pPr marL="1371600" indent="0">
               <a:buNone/>
-              <a:defRPr sz="900"/>
+              <a:defRPr sz="1000"/>
             </a:lvl4pPr>
             <a:lvl5pPr marL="1828800" indent="0">
               <a:buNone/>
-              <a:defRPr sz="900"/>
+              <a:defRPr sz="1000"/>
             </a:lvl5pPr>
             <a:lvl6pPr marL="2286000" indent="0">
               <a:buNone/>
-              <a:defRPr sz="900"/>
+              <a:defRPr sz="1000"/>
             </a:lvl6pPr>
             <a:lvl7pPr marL="2743200" indent="0">
               <a:buNone/>
-              <a:defRPr sz="900"/>
+              <a:defRPr sz="1000"/>
             </a:lvl7pPr>
             <a:lvl8pPr marL="3200400" indent="0">
               <a:buNone/>
-              <a:defRPr sz="900"/>
+              <a:defRPr sz="1000"/>
             </a:lvl8pPr>
             <a:lvl9pPr marL="3657600" indent="0">
               <a:buNone/>
-              <a:defRPr sz="900"/>
+              <a:defRPr sz="1000"/>
             </a:lvl9pPr>
           </a:lstStyle>
           <a:p>
             <a:pPr lvl="0"/>
             <a:r>
+              <a:rPr lang="en-US"/>
+              <a:t>Click to edit Master text styles</a:t>
+            </a:r>
+          </a:p>
+        </p:txBody>
+      </p:sp>
+      <p:sp>
+        <p:nvSpPr>
+          <p:cNvPr id="5" name="Date Placeholder 4">
+            <a:extLst>
+              <a:ext uri="{FF2B5EF4-FFF2-40B4-BE49-F238E27FC236}">
+                <a16:creationId xmlns:a16="http://schemas.microsoft.com/office/drawing/2014/main" id="{D63E0077-8282-07D8-8B32-EB75A2421B03}"/>
+              </a:ext>
+            </a:extLst>
+          </p:cNvPr>
+          <p:cNvSpPr>
+            <a:spLocks noGrp="1"/>
+          </p:cNvSpPr>
+          <p:nvPr>
+            <p:ph type="dt" sz="half" idx="10"/>
+          </p:nvPr>
+        </p:nvSpPr>
+        <p:spPr/>
+        <p:txBody>
+          <a:bodyPr/>
+          <a:lstStyle/>
+          <a:p>
+            <a:fld id="{889D59F5-FA95-4135-83D3-8A6DCE68FA7F}" type="datetimeFigureOut">
               <a:rPr lang="en-US" smtClean="0"/>
-              <a:t>Click to edit Master text styles</a:t>
-            </a:r>
-          </a:p>
-        </p:txBody>
-      </p:sp>
-      <p:sp>
-        <p:nvSpPr>
-          <p:cNvPr id="5" name="Date Placeholder 4"/>
-          <p:cNvSpPr>
-            <a:spLocks noGrp="1"/>
-          </p:cNvSpPr>
-          <p:nvPr>
-            <p:ph type="dt" sz="half" idx="10"/>
-          </p:nvPr>
-        </p:nvSpPr>
-        <p:spPr/>
-        <p:txBody>
-          <a:bodyPr/>
-          <a:lstStyle/>
-          <a:p>
-            <a:fld id="{5BCAD085-E8A6-8845-BD4E-CB4CCA059FC4}" type="datetimeFigureOut">
-              <a:rPr lang="en-US" smtClean="0"/>
-              <a:t>1/27/13</a:t>
+              <a:t>1/10/2023</a:t>
             </a:fld>
             <a:endParaRPr lang="en-US"/>
           </a:p>
@@ -2263,7 +2384,13 @@
       </p:sp>
       <p:sp>
         <p:nvSpPr>
-          <p:cNvPr id="6" name="Footer Placeholder 5"/>
+          <p:cNvPr id="6" name="Footer Placeholder 5">
+            <a:extLst>
+              <a:ext uri="{FF2B5EF4-FFF2-40B4-BE49-F238E27FC236}">
+                <a16:creationId xmlns:a16="http://schemas.microsoft.com/office/drawing/2014/main" id="{3E2C774A-C5BB-60DF-9C0D-70158E986C15}"/>
+              </a:ext>
+            </a:extLst>
+          </p:cNvPr>
           <p:cNvSpPr>
             <a:spLocks noGrp="1"/>
           </p:cNvSpPr>
@@ -2282,7 +2409,13 @@
       </p:sp>
       <p:sp>
         <p:nvSpPr>
-          <p:cNvPr id="7" name="Slide Number Placeholder 6"/>
+          <p:cNvPr id="7" name="Slide Number Placeholder 6">
+            <a:extLst>
+              <a:ext uri="{FF2B5EF4-FFF2-40B4-BE49-F238E27FC236}">
+                <a16:creationId xmlns:a16="http://schemas.microsoft.com/office/drawing/2014/main" id="{B7C45F7E-49C0-A4D4-CA72-76E4BB57CBE0}"/>
+              </a:ext>
+            </a:extLst>
+          </p:cNvPr>
           <p:cNvSpPr>
             <a:spLocks noGrp="1"/>
           </p:cNvSpPr>
@@ -2295,7 +2428,7 @@
           <a:bodyPr/>
           <a:lstStyle/>
           <a:p>
-            <a:fld id="{C1FF6DA9-008F-8B48-92A6-B652298478BF}" type="slidenum">
+            <a:fld id="{5D3F3E41-C438-4411-9D33-2B0DE7F3C933}" type="slidenum">
               <a:rPr lang="en-US" smtClean="0"/>
               <a:t>‹#›</a:t>
             </a:fld>
@@ -2306,7 +2439,7 @@
     </p:spTree>
     <p:extLst>
       <p:ext uri="{BB962C8B-B14F-4D97-AF65-F5344CB8AC3E}">
-        <p14:creationId xmlns:p14="http://schemas.microsoft.com/office/powerpoint/2010/main" val="1840726560"/>
+        <p14:creationId xmlns:p14="http://schemas.microsoft.com/office/powerpoint/2010/main" val="948713429"/>
       </p:ext>
     </p:extLst>
   </p:cSld>
@@ -2335,7 +2468,13 @@
       </p:grpSpPr>
       <p:sp>
         <p:nvSpPr>
-          <p:cNvPr id="2" name="Title 1"/>
+          <p:cNvPr id="2" name="Title 1">
+            <a:extLst>
+              <a:ext uri="{FF2B5EF4-FFF2-40B4-BE49-F238E27FC236}">
+                <a16:creationId xmlns:a16="http://schemas.microsoft.com/office/drawing/2014/main" id="{2018846E-D393-7741-713D-39879328AEBD}"/>
+              </a:ext>
+            </a:extLst>
+          </p:cNvPr>
           <p:cNvSpPr>
             <a:spLocks noGrp="1"/>
           </p:cNvSpPr>
@@ -2345,29 +2484,34 @@
         </p:nvSpPr>
         <p:spPr>
           <a:xfrm>
-            <a:off x="1792288" y="4800600"/>
-            <a:ext cx="5486400" cy="566738"/>
+            <a:off x="839788" y="457200"/>
+            <a:ext cx="3932237" cy="1600200"/>
           </a:xfrm>
         </p:spPr>
         <p:txBody>
           <a:bodyPr anchor="b"/>
           <a:lstStyle>
-            <a:lvl1pPr algn="l">
-              <a:defRPr sz="2000" b="1"/>
+            <a:lvl1pPr>
+              <a:defRPr sz="3200"/>
             </a:lvl1pPr>
           </a:lstStyle>
           <a:p>
             <a:r>
-              <a:rPr lang="en-US" smtClean="0"/>
+              <a:rPr lang="en-US"/>
               <a:t>Click to edit Master title style</a:t>
             </a:r>
-            <a:endParaRPr lang="en-US"/>
-          </a:p>
-        </p:txBody>
-      </p:sp>
-      <p:sp>
-        <p:nvSpPr>
-          <p:cNvPr id="3" name="Picture Placeholder 2"/>
+          </a:p>
+        </p:txBody>
+      </p:sp>
+      <p:sp>
+        <p:nvSpPr>
+          <p:cNvPr id="3" name="Picture Placeholder 2">
+            <a:extLst>
+              <a:ext uri="{FF2B5EF4-FFF2-40B4-BE49-F238E27FC236}">
+                <a16:creationId xmlns:a16="http://schemas.microsoft.com/office/drawing/2014/main" id="{23C6BC1F-B6B8-E15A-E089-0FDE55DA24A1}"/>
+              </a:ext>
+            </a:extLst>
+          </p:cNvPr>
           <p:cNvSpPr>
             <a:spLocks noGrp="1"/>
           </p:cNvSpPr>
@@ -2377,8 +2521,8 @@
         </p:nvSpPr>
         <p:spPr>
           <a:xfrm>
-            <a:off x="1792288" y="612775"/>
-            <a:ext cx="5486400" cy="4114800"/>
+            <a:off x="5183188" y="987425"/>
+            <a:ext cx="6172200" cy="4873625"/>
           </a:xfrm>
         </p:spPr>
         <p:txBody>
@@ -2428,7 +2572,13 @@
       </p:sp>
       <p:sp>
         <p:nvSpPr>
-          <p:cNvPr id="4" name="Text Placeholder 3"/>
+          <p:cNvPr id="4" name="Text Placeholder 3">
+            <a:extLst>
+              <a:ext uri="{FF2B5EF4-FFF2-40B4-BE49-F238E27FC236}">
+                <a16:creationId xmlns:a16="http://schemas.microsoft.com/office/drawing/2014/main" id="{61A4F38B-A480-87C0-F76F-A5DE2D6C3DEB}"/>
+              </a:ext>
+            </a:extLst>
+          </p:cNvPr>
           <p:cNvSpPr>
             <a:spLocks noGrp="1"/>
           </p:cNvSpPr>
@@ -2438,8 +2588,8 @@
         </p:nvSpPr>
         <p:spPr>
           <a:xfrm>
-            <a:off x="1792288" y="5367338"/>
-            <a:ext cx="5486400" cy="804862"/>
+            <a:off x="839788" y="2057400"/>
+            <a:ext cx="3932237" cy="3811588"/>
           </a:xfrm>
         </p:spPr>
         <p:txBody>
@@ -2447,68 +2597,74 @@
           <a:lstStyle>
             <a:lvl1pPr marL="0" indent="0">
               <a:buNone/>
-              <a:defRPr sz="1400"/>
+              <a:defRPr sz="1600"/>
             </a:lvl1pPr>
             <a:lvl2pPr marL="457200" indent="0">
               <a:buNone/>
-              <a:defRPr sz="1200"/>
+              <a:defRPr sz="1400"/>
             </a:lvl2pPr>
             <a:lvl3pPr marL="914400" indent="0">
               <a:buNone/>
-              <a:defRPr sz="1000"/>
+              <a:defRPr sz="1200"/>
             </a:lvl3pPr>
             <a:lvl4pPr marL="1371600" indent="0">
               <a:buNone/>
-              <a:defRPr sz="900"/>
+              <a:defRPr sz="1000"/>
             </a:lvl4pPr>
             <a:lvl5pPr marL="1828800" indent="0">
               <a:buNone/>
-              <a:defRPr sz="900"/>
+              <a:defRPr sz="1000"/>
             </a:lvl5pPr>
             <a:lvl6pPr marL="2286000" indent="0">
               <a:buNone/>
-              <a:defRPr sz="900"/>
+              <a:defRPr sz="1000"/>
             </a:lvl6pPr>
             <a:lvl7pPr marL="2743200" indent="0">
               <a:buNone/>
-              <a:defRPr sz="900"/>
+              <a:defRPr sz="1000"/>
             </a:lvl7pPr>
             <a:lvl8pPr marL="3200400" indent="0">
               <a:buNone/>
-              <a:defRPr sz="900"/>
+              <a:defRPr sz="1000"/>
             </a:lvl8pPr>
             <a:lvl9pPr marL="3657600" indent="0">
               <a:buNone/>
-              <a:defRPr sz="900"/>
+              <a:defRPr sz="1000"/>
             </a:lvl9pPr>
           </a:lstStyle>
           <a:p>
             <a:pPr lvl="0"/>
             <a:r>
+              <a:rPr lang="en-US"/>
+              <a:t>Click to edit Master text styles</a:t>
+            </a:r>
+          </a:p>
+        </p:txBody>
+      </p:sp>
+      <p:sp>
+        <p:nvSpPr>
+          <p:cNvPr id="5" name="Date Placeholder 4">
+            <a:extLst>
+              <a:ext uri="{FF2B5EF4-FFF2-40B4-BE49-F238E27FC236}">
+                <a16:creationId xmlns:a16="http://schemas.microsoft.com/office/drawing/2014/main" id="{A6604A44-F4E7-B41D-93CC-288559B8C213}"/>
+              </a:ext>
+            </a:extLst>
+          </p:cNvPr>
+          <p:cNvSpPr>
+            <a:spLocks noGrp="1"/>
+          </p:cNvSpPr>
+          <p:nvPr>
+            <p:ph type="dt" sz="half" idx="10"/>
+          </p:nvPr>
+        </p:nvSpPr>
+        <p:spPr/>
+        <p:txBody>
+          <a:bodyPr/>
+          <a:lstStyle/>
+          <a:p>
+            <a:fld id="{889D59F5-FA95-4135-83D3-8A6DCE68FA7F}" type="datetimeFigureOut">
               <a:rPr lang="en-US" smtClean="0"/>
-              <a:t>Click to edit Master text styles</a:t>
-            </a:r>
-          </a:p>
-        </p:txBody>
-      </p:sp>
-      <p:sp>
-        <p:nvSpPr>
-          <p:cNvPr id="5" name="Date Placeholder 4"/>
-          <p:cNvSpPr>
-            <a:spLocks noGrp="1"/>
-          </p:cNvSpPr>
-          <p:nvPr>
-            <p:ph type="dt" sz="half" idx="10"/>
-          </p:nvPr>
-        </p:nvSpPr>
-        <p:spPr/>
-        <p:txBody>
-          <a:bodyPr/>
-          <a:lstStyle/>
-          <a:p>
-            <a:fld id="{5BCAD085-E8A6-8845-BD4E-CB4CCA059FC4}" type="datetimeFigureOut">
-              <a:rPr lang="en-US" smtClean="0"/>
-              <a:t>1/27/13</a:t>
+              <a:t>1/10/2023</a:t>
             </a:fld>
             <a:endParaRPr lang="en-US"/>
           </a:p>
@@ -2516,7 +2672,13 @@
       </p:sp>
       <p:sp>
         <p:nvSpPr>
-          <p:cNvPr id="6" name="Footer Placeholder 5"/>
+          <p:cNvPr id="6" name="Footer Placeholder 5">
+            <a:extLst>
+              <a:ext uri="{FF2B5EF4-FFF2-40B4-BE49-F238E27FC236}">
+                <a16:creationId xmlns:a16="http://schemas.microsoft.com/office/drawing/2014/main" id="{B36E0BF5-753A-7DD2-BFD7-399B48C58FB5}"/>
+              </a:ext>
+            </a:extLst>
+          </p:cNvPr>
           <p:cNvSpPr>
             <a:spLocks noGrp="1"/>
           </p:cNvSpPr>
@@ -2535,7 +2697,13 @@
       </p:sp>
       <p:sp>
         <p:nvSpPr>
-          <p:cNvPr id="7" name="Slide Number Placeholder 6"/>
+          <p:cNvPr id="7" name="Slide Number Placeholder 6">
+            <a:extLst>
+              <a:ext uri="{FF2B5EF4-FFF2-40B4-BE49-F238E27FC236}">
+                <a16:creationId xmlns:a16="http://schemas.microsoft.com/office/drawing/2014/main" id="{712B235D-C95C-C69A-B18D-B03B62C61781}"/>
+              </a:ext>
+            </a:extLst>
+          </p:cNvPr>
           <p:cNvSpPr>
             <a:spLocks noGrp="1"/>
           </p:cNvSpPr>
@@ -2548,7 +2716,7 @@
           <a:bodyPr/>
           <a:lstStyle/>
           <a:p>
-            <a:fld id="{C1FF6DA9-008F-8B48-92A6-B652298478BF}" type="slidenum">
+            <a:fld id="{5D3F3E41-C438-4411-9D33-2B0DE7F3C933}" type="slidenum">
               <a:rPr lang="en-US" smtClean="0"/>
               <a:t>‹#›</a:t>
             </a:fld>
@@ -2559,7 +2727,7 @@
     </p:spTree>
     <p:extLst>
       <p:ext uri="{BB962C8B-B14F-4D97-AF65-F5344CB8AC3E}">
-        <p14:creationId xmlns:p14="http://schemas.microsoft.com/office/powerpoint/2010/main" val="3889236939"/>
+        <p14:creationId xmlns:p14="http://schemas.microsoft.com/office/powerpoint/2010/main" val="2933360032"/>
       </p:ext>
     </p:extLst>
   </p:cSld>
@@ -2593,7 +2761,13 @@
       </p:grpSpPr>
       <p:sp>
         <p:nvSpPr>
-          <p:cNvPr id="2" name="Title Placeholder 1"/>
+          <p:cNvPr id="2" name="Title Placeholder 1">
+            <a:extLst>
+              <a:ext uri="{FF2B5EF4-FFF2-40B4-BE49-F238E27FC236}">
+                <a16:creationId xmlns:a16="http://schemas.microsoft.com/office/drawing/2014/main" id="{283A4D3C-CE55-A56F-8CD6-B3BB48138A87}"/>
+              </a:ext>
+            </a:extLst>
+          </p:cNvPr>
           <p:cNvSpPr>
             <a:spLocks noGrp="1"/>
           </p:cNvSpPr>
@@ -2603,8 +2777,8 @@
         </p:nvSpPr>
         <p:spPr>
           <a:xfrm>
-            <a:off x="457200" y="274638"/>
-            <a:ext cx="8229600" cy="1143000"/>
+            <a:off x="838200" y="365125"/>
+            <a:ext cx="10515600" cy="1325563"/>
           </a:xfrm>
           <a:prstGeom prst="rect">
             <a:avLst/>
@@ -2617,16 +2791,21 @@
           <a:lstStyle/>
           <a:p>
             <a:r>
-              <a:rPr lang="en-US" smtClean="0"/>
+              <a:rPr lang="en-US"/>
               <a:t>Click to edit Master title style</a:t>
             </a:r>
-            <a:endParaRPr lang="en-US"/>
-          </a:p>
-        </p:txBody>
-      </p:sp>
-      <p:sp>
-        <p:nvSpPr>
-          <p:cNvPr id="3" name="Text Placeholder 2"/>
+          </a:p>
+        </p:txBody>
+      </p:sp>
+      <p:sp>
+        <p:nvSpPr>
+          <p:cNvPr id="3" name="Text Placeholder 2">
+            <a:extLst>
+              <a:ext uri="{FF2B5EF4-FFF2-40B4-BE49-F238E27FC236}">
+                <a16:creationId xmlns:a16="http://schemas.microsoft.com/office/drawing/2014/main" id="{12C31888-7F35-68ED-42B7-C716F780AB32}"/>
+              </a:ext>
+            </a:extLst>
+          </p:cNvPr>
           <p:cNvSpPr>
             <a:spLocks noGrp="1"/>
           </p:cNvSpPr>
@@ -2636,8 +2815,8 @@
         </p:nvSpPr>
         <p:spPr>
           <a:xfrm>
-            <a:off x="457200" y="1600200"/>
-            <a:ext cx="8229600" cy="4525963"/>
+            <a:off x="838200" y="1825625"/>
+            <a:ext cx="10515600" cy="4351338"/>
           </a:xfrm>
           <a:prstGeom prst="rect">
             <a:avLst/>
@@ -2651,44 +2830,49 @@
           <a:p>
             <a:pPr lvl="0"/>
             <a:r>
-              <a:rPr lang="en-US" smtClean="0"/>
+              <a:rPr lang="en-US"/>
               <a:t>Click to edit Master text styles</a:t>
             </a:r>
           </a:p>
           <a:p>
             <a:pPr lvl="1"/>
             <a:r>
-              <a:rPr lang="en-US" smtClean="0"/>
+              <a:rPr lang="en-US"/>
               <a:t>Second level</a:t>
             </a:r>
           </a:p>
           <a:p>
             <a:pPr lvl="2"/>
             <a:r>
-              <a:rPr lang="en-US" smtClean="0"/>
+              <a:rPr lang="en-US"/>
               <a:t>Third level</a:t>
             </a:r>
           </a:p>
           <a:p>
             <a:pPr lvl="3"/>
             <a:r>
-              <a:rPr lang="en-US" smtClean="0"/>
+              <a:rPr lang="en-US"/>
               <a:t>Fourth level</a:t>
             </a:r>
           </a:p>
           <a:p>
             <a:pPr lvl="4"/>
             <a:r>
-              <a:rPr lang="en-US" smtClean="0"/>
+              <a:rPr lang="en-US"/>
               <a:t>Fifth level</a:t>
             </a:r>
-            <a:endParaRPr lang="en-US"/>
-          </a:p>
-        </p:txBody>
-      </p:sp>
-      <p:sp>
-        <p:nvSpPr>
-          <p:cNvPr id="4" name="Date Placeholder 3"/>
+          </a:p>
+        </p:txBody>
+      </p:sp>
+      <p:sp>
+        <p:nvSpPr>
+          <p:cNvPr id="4" name="Date Placeholder 3">
+            <a:extLst>
+              <a:ext uri="{FF2B5EF4-FFF2-40B4-BE49-F238E27FC236}">
+                <a16:creationId xmlns:a16="http://schemas.microsoft.com/office/drawing/2014/main" id="{CBB7C301-F7B8-4E45-BA69-1E7C8BC9BA81}"/>
+              </a:ext>
+            </a:extLst>
+          </p:cNvPr>
           <p:cNvSpPr>
             <a:spLocks noGrp="1"/>
           </p:cNvSpPr>
@@ -2698,8 +2882,8 @@
         </p:nvSpPr>
         <p:spPr>
           <a:xfrm>
-            <a:off x="457200" y="6356350"/>
-            <a:ext cx="2133600" cy="365125"/>
+            <a:off x="838200" y="6356350"/>
+            <a:ext cx="2743200" cy="365125"/>
           </a:xfrm>
           <a:prstGeom prst="rect">
             <a:avLst/>
@@ -2719,9 +2903,9 @@
             </a:lvl1pPr>
           </a:lstStyle>
           <a:p>
-            <a:fld id="{5BCAD085-E8A6-8845-BD4E-CB4CCA059FC4}" type="datetimeFigureOut">
+            <a:fld id="{889D59F5-FA95-4135-83D3-8A6DCE68FA7F}" type="datetimeFigureOut">
               <a:rPr lang="en-US" smtClean="0"/>
-              <a:t>1/27/13</a:t>
+              <a:t>1/10/2023</a:t>
             </a:fld>
             <a:endParaRPr lang="en-US"/>
           </a:p>
@@ -2729,7 +2913,13 @@
       </p:sp>
       <p:sp>
         <p:nvSpPr>
-          <p:cNvPr id="5" name="Footer Placeholder 4"/>
+          <p:cNvPr id="5" name="Footer Placeholder 4">
+            <a:extLst>
+              <a:ext uri="{FF2B5EF4-FFF2-40B4-BE49-F238E27FC236}">
+                <a16:creationId xmlns:a16="http://schemas.microsoft.com/office/drawing/2014/main" id="{2E3EF65E-85AE-0BE7-B064-B6C02D204D91}"/>
+              </a:ext>
+            </a:extLst>
+          </p:cNvPr>
           <p:cNvSpPr>
             <a:spLocks noGrp="1"/>
           </p:cNvSpPr>
@@ -2739,8 +2929,8 @@
         </p:nvSpPr>
         <p:spPr>
           <a:xfrm>
-            <a:off x="3124200" y="6356350"/>
-            <a:ext cx="2895600" cy="365125"/>
+            <a:off x="4038600" y="6356350"/>
+            <a:ext cx="4114800" cy="365125"/>
           </a:xfrm>
           <a:prstGeom prst="rect">
             <a:avLst/>
@@ -2766,7 +2956,13 @@
       </p:sp>
       <p:sp>
         <p:nvSpPr>
-          <p:cNvPr id="6" name="Slide Number Placeholder 5"/>
+          <p:cNvPr id="6" name="Slide Number Placeholder 5">
+            <a:extLst>
+              <a:ext uri="{FF2B5EF4-FFF2-40B4-BE49-F238E27FC236}">
+                <a16:creationId xmlns:a16="http://schemas.microsoft.com/office/drawing/2014/main" id="{5B7FD831-CC9D-2412-598D-62FB41491024}"/>
+              </a:ext>
+            </a:extLst>
+          </p:cNvPr>
           <p:cNvSpPr>
             <a:spLocks noGrp="1"/>
           </p:cNvSpPr>
@@ -2776,8 +2972,8 @@
         </p:nvSpPr>
         <p:spPr>
           <a:xfrm>
-            <a:off x="6553200" y="6356350"/>
-            <a:ext cx="2133600" cy="365125"/>
+            <a:off x="8610600" y="6356350"/>
+            <a:ext cx="2743200" cy="365125"/>
           </a:xfrm>
           <a:prstGeom prst="rect">
             <a:avLst/>
@@ -2797,7 +2993,7 @@
             </a:lvl1pPr>
           </a:lstStyle>
           <a:p>
-            <a:fld id="{C1FF6DA9-008F-8B48-92A6-B652298478BF}" type="slidenum">
+            <a:fld id="{5D3F3E41-C438-4411-9D33-2B0DE7F3C933}" type="slidenum">
               <a:rPr lang="en-US" smtClean="0"/>
               <a:t>‹#›</a:t>
             </a:fld>
@@ -2808,7 +3004,7 @@
     </p:spTree>
     <p:extLst>
       <p:ext uri="{BB962C8B-B14F-4D97-AF65-F5344CB8AC3E}">
-        <p14:creationId xmlns:p14="http://schemas.microsoft.com/office/powerpoint/2010/main" val="2209977519"/>
+        <p14:creationId xmlns:p14="http://schemas.microsoft.com/office/powerpoint/2010/main" val="2122641938"/>
       </p:ext>
     </p:extLst>
   </p:cSld>
@@ -2828,7 +3024,10 @@
   </p:sldLayoutIdLst>
   <p:txStyles>
     <p:titleStyle>
-      <a:lvl1pPr algn="ctr" defTabSz="457200" rtl="0" eaLnBrk="1" latinLnBrk="0" hangingPunct="1">
+      <a:lvl1pPr algn="l" defTabSz="914400" rtl="0" eaLnBrk="1" latinLnBrk="0" hangingPunct="1">
+        <a:lnSpc>
+          <a:spcPct val="90000"/>
+        </a:lnSpc>
         <a:spcBef>
           <a:spcPct val="0"/>
         </a:spcBef>
@@ -2844,13 +3043,16 @@
       </a:lvl1pPr>
     </p:titleStyle>
     <p:bodyStyle>
-      <a:lvl1pPr marL="342900" indent="-342900" algn="l" defTabSz="457200" rtl="0" eaLnBrk="1" latinLnBrk="0" hangingPunct="1">
+      <a:lvl1pPr marL="228600" indent="-228600" algn="l" defTabSz="914400" rtl="0" eaLnBrk="1" latinLnBrk="0" hangingPunct="1">
+        <a:lnSpc>
+          <a:spcPct val="90000"/>
+        </a:lnSpc>
         <a:spcBef>
-          <a:spcPct val="20000"/>
+          <a:spcPts val="1000"/>
         </a:spcBef>
-        <a:buFont typeface="Arial"/>
+        <a:buFont typeface="Arial" panose="020B0604020202020204" pitchFamily="34" charset="0"/>
         <a:buChar char="•"/>
-        <a:defRPr sz="3200" kern="1200">
+        <a:defRPr sz="2800" kern="1200">
           <a:solidFill>
             <a:schemeClr val="tx1"/>
           </a:solidFill>
@@ -2859,26 +3061,14 @@
           <a:cs typeface="+mn-cs"/>
         </a:defRPr>
       </a:lvl1pPr>
-      <a:lvl2pPr marL="742950" indent="-285750" algn="l" defTabSz="457200" rtl="0" eaLnBrk="1" latinLnBrk="0" hangingPunct="1">
+      <a:lvl2pPr marL="685800" indent="-228600" algn="l" defTabSz="914400" rtl="0" eaLnBrk="1" latinLnBrk="0" hangingPunct="1">
+        <a:lnSpc>
+          <a:spcPct val="90000"/>
+        </a:lnSpc>
         <a:spcBef>
-          <a:spcPct val="20000"/>
+          <a:spcPts val="500"/>
         </a:spcBef>
-        <a:buFont typeface="Arial"/>
-        <a:buChar char="–"/>
-        <a:defRPr sz="2800" kern="1200">
-          <a:solidFill>
-            <a:schemeClr val="tx1"/>
-          </a:solidFill>
-          <a:latin typeface="+mn-lt"/>
-          <a:ea typeface="+mn-ea"/>
-          <a:cs typeface="+mn-cs"/>
-        </a:defRPr>
-      </a:lvl2pPr>
-      <a:lvl3pPr marL="1143000" indent="-228600" algn="l" defTabSz="457200" rtl="0" eaLnBrk="1" latinLnBrk="0" hangingPunct="1">
-        <a:spcBef>
-          <a:spcPct val="20000"/>
-        </a:spcBef>
-        <a:buFont typeface="Arial"/>
+        <a:buFont typeface="Arial" panose="020B0604020202020204" pitchFamily="34" charset="0"/>
         <a:buChar char="•"/>
         <a:defRPr sz="2400" kern="1200">
           <a:solidFill>
@@ -2888,42 +3078,15 @@
           <a:ea typeface="+mn-ea"/>
           <a:cs typeface="+mn-cs"/>
         </a:defRPr>
-      </a:lvl3pPr>
-      <a:lvl4pPr marL="1600200" indent="-228600" algn="l" defTabSz="457200" rtl="0" eaLnBrk="1" latinLnBrk="0" hangingPunct="1">
+      </a:lvl2pPr>
+      <a:lvl3pPr marL="1143000" indent="-228600" algn="l" defTabSz="914400" rtl="0" eaLnBrk="1" latinLnBrk="0" hangingPunct="1">
+        <a:lnSpc>
+          <a:spcPct val="90000"/>
+        </a:lnSpc>
         <a:spcBef>
-          <a:spcPct val="20000"/>
+          <a:spcPts val="500"/>
         </a:spcBef>
-        <a:buFont typeface="Arial"/>
-        <a:buChar char="–"/>
-        <a:defRPr sz="2000" kern="1200">
-          <a:solidFill>
-            <a:schemeClr val="tx1"/>
-          </a:solidFill>
-          <a:latin typeface="+mn-lt"/>
-          <a:ea typeface="+mn-ea"/>
-          <a:cs typeface="+mn-cs"/>
-        </a:defRPr>
-      </a:lvl4pPr>
-      <a:lvl5pPr marL="2057400" indent="-228600" algn="l" defTabSz="457200" rtl="0" eaLnBrk="1" latinLnBrk="0" hangingPunct="1">
-        <a:spcBef>
-          <a:spcPct val="20000"/>
-        </a:spcBef>
-        <a:buFont typeface="Arial"/>
-        <a:buChar char="»"/>
-        <a:defRPr sz="2000" kern="1200">
-          <a:solidFill>
-            <a:schemeClr val="tx1"/>
-          </a:solidFill>
-          <a:latin typeface="+mn-lt"/>
-          <a:ea typeface="+mn-ea"/>
-          <a:cs typeface="+mn-cs"/>
-        </a:defRPr>
-      </a:lvl5pPr>
-      <a:lvl6pPr marL="2514600" indent="-228600" algn="l" defTabSz="457200" rtl="0" eaLnBrk="1" latinLnBrk="0" hangingPunct="1">
-        <a:spcBef>
-          <a:spcPct val="20000"/>
-        </a:spcBef>
-        <a:buFont typeface="Arial"/>
+        <a:buFont typeface="Arial" panose="020B0604020202020204" pitchFamily="34" charset="0"/>
         <a:buChar char="•"/>
         <a:defRPr sz="2000" kern="1200">
           <a:solidFill>
@@ -2933,14 +3096,71 @@
           <a:ea typeface="+mn-ea"/>
           <a:cs typeface="+mn-cs"/>
         </a:defRPr>
+      </a:lvl3pPr>
+      <a:lvl4pPr marL="1600200" indent="-228600" algn="l" defTabSz="914400" rtl="0" eaLnBrk="1" latinLnBrk="0" hangingPunct="1">
+        <a:lnSpc>
+          <a:spcPct val="90000"/>
+        </a:lnSpc>
+        <a:spcBef>
+          <a:spcPts val="500"/>
+        </a:spcBef>
+        <a:buFont typeface="Arial" panose="020B0604020202020204" pitchFamily="34" charset="0"/>
+        <a:buChar char="•"/>
+        <a:defRPr sz="1800" kern="1200">
+          <a:solidFill>
+            <a:schemeClr val="tx1"/>
+          </a:solidFill>
+          <a:latin typeface="+mn-lt"/>
+          <a:ea typeface="+mn-ea"/>
+          <a:cs typeface="+mn-cs"/>
+        </a:defRPr>
+      </a:lvl4pPr>
+      <a:lvl5pPr marL="2057400" indent="-228600" algn="l" defTabSz="914400" rtl="0" eaLnBrk="1" latinLnBrk="0" hangingPunct="1">
+        <a:lnSpc>
+          <a:spcPct val="90000"/>
+        </a:lnSpc>
+        <a:spcBef>
+          <a:spcPts val="500"/>
+        </a:spcBef>
+        <a:buFont typeface="Arial" panose="020B0604020202020204" pitchFamily="34" charset="0"/>
+        <a:buChar char="•"/>
+        <a:defRPr sz="1800" kern="1200">
+          <a:solidFill>
+            <a:schemeClr val="tx1"/>
+          </a:solidFill>
+          <a:latin typeface="+mn-lt"/>
+          <a:ea typeface="+mn-ea"/>
+          <a:cs typeface="+mn-cs"/>
+        </a:defRPr>
+      </a:lvl5pPr>
+      <a:lvl6pPr marL="2514600" indent="-228600" algn="l" defTabSz="914400" rtl="0" eaLnBrk="1" latinLnBrk="0" hangingPunct="1">
+        <a:lnSpc>
+          <a:spcPct val="90000"/>
+        </a:lnSpc>
+        <a:spcBef>
+          <a:spcPts val="500"/>
+        </a:spcBef>
+        <a:buFont typeface="Arial" panose="020B0604020202020204" pitchFamily="34" charset="0"/>
+        <a:buChar char="•"/>
+        <a:defRPr sz="1800" kern="1200">
+          <a:solidFill>
+            <a:schemeClr val="tx1"/>
+          </a:solidFill>
+          <a:latin typeface="+mn-lt"/>
+          <a:ea typeface="+mn-ea"/>
+          <a:cs typeface="+mn-cs"/>
+        </a:defRPr>
       </a:lvl6pPr>
-      <a:lvl7pPr marL="2971800" indent="-228600" algn="l" defTabSz="457200" rtl="0" eaLnBrk="1" latinLnBrk="0" hangingPunct="1">
+      <a:lvl7pPr marL="2971800" indent="-228600" algn="l" defTabSz="914400" rtl="0" eaLnBrk="1" latinLnBrk="0" hangingPunct="1">
+        <a:lnSpc>
+          <a:spcPct val="90000"/>
+        </a:lnSpc>
         <a:spcBef>
-          <a:spcPct val="20000"/>
+          <a:spcPts val="500"/>
         </a:spcBef>
-        <a:buFont typeface="Arial"/>
+        <a:buFont typeface="Arial" panose="020B0604020202020204" pitchFamily="34" charset="0"/>
         <a:buChar char="•"/>
-        <a:defRPr sz="2000" kern="1200">
+        <a:defRPr sz="1800" kern="1200">
           <a:solidFill>
             <a:schemeClr val="tx1"/>
           </a:solidFill>
@@ -2949,13 +3169,16 @@
           <a:cs typeface="+mn-cs"/>
         </a:defRPr>
       </a:lvl7pPr>
-      <a:lvl8pPr marL="3429000" indent="-228600" algn="l" defTabSz="457200" rtl="0" eaLnBrk="1" latinLnBrk="0" hangingPunct="1">
+      <a:lvl8pPr marL="3429000" indent="-228600" algn="l" defTabSz="914400" rtl="0" eaLnBrk="1" latinLnBrk="0" hangingPunct="1">
+        <a:lnSpc>
+          <a:spcPct val="90000"/>
+        </a:lnSpc>
         <a:spcBef>
-          <a:spcPct val="20000"/>
+          <a:spcPts val="500"/>
         </a:spcBef>
-        <a:buFont typeface="Arial"/>
+        <a:buFont typeface="Arial" panose="020B0604020202020204" pitchFamily="34" charset="0"/>
         <a:buChar char="•"/>
-        <a:defRPr sz="2000" kern="1200">
+        <a:defRPr sz="1800" kern="1200">
           <a:solidFill>
             <a:schemeClr val="tx1"/>
           </a:solidFill>
@@ -2964,13 +3187,16 @@
           <a:cs typeface="+mn-cs"/>
         </a:defRPr>
       </a:lvl8pPr>
-      <a:lvl9pPr marL="3886200" indent="-228600" algn="l" defTabSz="457200" rtl="0" eaLnBrk="1" latinLnBrk="0" hangingPunct="1">
+      <a:lvl9pPr marL="3886200" indent="-228600" algn="l" defTabSz="914400" rtl="0" eaLnBrk="1" latinLnBrk="0" hangingPunct="1">
+        <a:lnSpc>
+          <a:spcPct val="90000"/>
+        </a:lnSpc>
         <a:spcBef>
-          <a:spcPct val="20000"/>
+          <a:spcPts val="500"/>
         </a:spcBef>
-        <a:buFont typeface="Arial"/>
+        <a:buFont typeface="Arial" panose="020B0604020202020204" pitchFamily="34" charset="0"/>
         <a:buChar char="•"/>
-        <a:defRPr sz="2000" kern="1200">
+        <a:defRPr sz="1800" kern="1200">
           <a:solidFill>
             <a:schemeClr val="tx1"/>
           </a:solidFill>
@@ -2984,7 +3210,7 @@
       <a:defPPr>
         <a:defRPr lang="en-US"/>
       </a:defPPr>
-      <a:lvl1pPr marL="0" algn="l" defTabSz="457200" rtl="0" eaLnBrk="1" latinLnBrk="0" hangingPunct="1">
+      <a:lvl1pPr marL="0" algn="l" defTabSz="914400" rtl="0" eaLnBrk="1" latinLnBrk="0" hangingPunct="1">
         <a:defRPr sz="1800" kern="1200">
           <a:solidFill>
             <a:schemeClr val="tx1"/>
@@ -2994,7 +3220,7 @@
           <a:cs typeface="+mn-cs"/>
         </a:defRPr>
       </a:lvl1pPr>
-      <a:lvl2pPr marL="457200" algn="l" defTabSz="457200" rtl="0" eaLnBrk="1" latinLnBrk="0" hangingPunct="1">
+      <a:lvl2pPr marL="457200" algn="l" defTabSz="914400" rtl="0" eaLnBrk="1" latinLnBrk="0" hangingPunct="1">
         <a:defRPr sz="1800" kern="1200">
           <a:solidFill>
             <a:schemeClr val="tx1"/>
@@ -3004,7 +3230,7 @@
           <a:cs typeface="+mn-cs"/>
         </a:defRPr>
       </a:lvl2pPr>
-      <a:lvl3pPr marL="914400" algn="l" defTabSz="457200" rtl="0" eaLnBrk="1" latinLnBrk="0" hangingPunct="1">
+      <a:lvl3pPr marL="914400" algn="l" defTabSz="914400" rtl="0" eaLnBrk="1" latinLnBrk="0" hangingPunct="1">
         <a:defRPr sz="1800" kern="1200">
           <a:solidFill>
             <a:schemeClr val="tx1"/>
@@ -3014,7 +3240,7 @@
           <a:cs typeface="+mn-cs"/>
         </a:defRPr>
       </a:lvl3pPr>
-      <a:lvl4pPr marL="1371600" algn="l" defTabSz="457200" rtl="0" eaLnBrk="1" latinLnBrk="0" hangingPunct="1">
+      <a:lvl4pPr marL="1371600" algn="l" defTabSz="914400" rtl="0" eaLnBrk="1" latinLnBrk="0" hangingPunct="1">
         <a:defRPr sz="1800" kern="1200">
           <a:solidFill>
             <a:schemeClr val="tx1"/>
@@ -3024,7 +3250,7 @@
           <a:cs typeface="+mn-cs"/>
         </a:defRPr>
       </a:lvl4pPr>
-      <a:lvl5pPr marL="1828800" algn="l" defTabSz="457200" rtl="0" eaLnBrk="1" latinLnBrk="0" hangingPunct="1">
+      <a:lvl5pPr marL="1828800" algn="l" defTabSz="914400" rtl="0" eaLnBrk="1" latinLnBrk="0" hangingPunct="1">
         <a:defRPr sz="1800" kern="1200">
           <a:solidFill>
             <a:schemeClr val="tx1"/>
@@ -3034,7 +3260,7 @@
           <a:cs typeface="+mn-cs"/>
         </a:defRPr>
       </a:lvl5pPr>
-      <a:lvl6pPr marL="2286000" algn="l" defTabSz="457200" rtl="0" eaLnBrk="1" latinLnBrk="0" hangingPunct="1">
+      <a:lvl6pPr marL="2286000" algn="l" defTabSz="914400" rtl="0" eaLnBrk="1" latinLnBrk="0" hangingPunct="1">
         <a:defRPr sz="1800" kern="1200">
           <a:solidFill>
             <a:schemeClr val="tx1"/>
@@ -3044,7 +3270,7 @@
           <a:cs typeface="+mn-cs"/>
         </a:defRPr>
       </a:lvl6pPr>
-      <a:lvl7pPr marL="2743200" algn="l" defTabSz="457200" rtl="0" eaLnBrk="1" latinLnBrk="0" hangingPunct="1">
+      <a:lvl7pPr marL="2743200" algn="l" defTabSz="914400" rtl="0" eaLnBrk="1" latinLnBrk="0" hangingPunct="1">
         <a:defRPr sz="1800" kern="1200">
           <a:solidFill>
             <a:schemeClr val="tx1"/>
@@ -3054,7 +3280,7 @@
           <a:cs typeface="+mn-cs"/>
         </a:defRPr>
       </a:lvl7pPr>
-      <a:lvl8pPr marL="3200400" algn="l" defTabSz="457200" rtl="0" eaLnBrk="1" latinLnBrk="0" hangingPunct="1">
+      <a:lvl8pPr marL="3200400" algn="l" defTabSz="914400" rtl="0" eaLnBrk="1" latinLnBrk="0" hangingPunct="1">
         <a:defRPr sz="1800" kern="1200">
           <a:solidFill>
             <a:schemeClr val="tx1"/>
@@ -3064,7 +3290,7 @@
           <a:cs typeface="+mn-cs"/>
         </a:defRPr>
       </a:lvl8pPr>
-      <a:lvl9pPr marL="3657600" algn="l" defTabSz="457200" rtl="0" eaLnBrk="1" latinLnBrk="0" hangingPunct="1">
+      <a:lvl9pPr marL="3657600" algn="l" defTabSz="914400" rtl="0" eaLnBrk="1" latinLnBrk="0" hangingPunct="1">
         <a:defRPr sz="1800" kern="1200">
           <a:solidFill>
             <a:schemeClr val="tx1"/>
@@ -3089,9 +3315,254 @@
         <p:nvPr/>
       </p:nvGrpSpPr>
       <p:grpSpPr/>
+      <p:sp>
+        <p:nvSpPr>
+          <p:cNvPr id="2" name="TextBox 1"/>
+          <p:cNvSpPr txBox="1"/>
+          <p:nvPr/>
+        </p:nvSpPr>
+        <p:spPr>
+          <a:xfrm>
+            <a:off x="1595170" y="628558"/>
+            <a:ext cx="1552559" cy="1200332"/>
+          </a:xfrm>
+          <a:prstGeom prst="rect">
+            <a:avLst/>
+          </a:prstGeom>
+          <a:noFill/>
+        </p:spPr>
+        <p:txBody>
+          <a:bodyPr wrap="square">
+            <a:spAutoFit/>
+          </a:bodyPr>
+          <a:lstStyle/>
+          <a:p>
+            <a:pPr lvl="0">
+              <a:buNone/>
+            </a:pPr>
+            <a:r>
+              <a:rPr b="1">
+                <a:solidFill>
+                  <a:srgbClr val="00B050"/>
+                </a:solidFill>
+              </a:rPr>
+              <a:t>Anonymous Donation Check Box</a:t>
+            </a:r>
+          </a:p>
+          <a:p>
+            <a:pPr lvl="0">
+              <a:buNone/>
+            </a:pPr>
+            <a:r>
+              <a:rPr b="1">
+                <a:solidFill>
+                  <a:srgbClr val="00B050"/>
+                </a:solidFill>
+              </a:rPr>
+              <a:t>Present</a:t>
+            </a:r>
+          </a:p>
+        </p:txBody>
+      </p:sp>
+      <p:sp>
+        <p:nvSpPr>
+          <p:cNvPr id="3" name="TextBox 2"/>
+          <p:cNvSpPr txBox="1"/>
+          <p:nvPr/>
+        </p:nvSpPr>
+        <p:spPr>
+          <a:xfrm>
+            <a:off x="1571670" y="4734306"/>
+            <a:ext cx="1552559" cy="1200332"/>
+          </a:xfrm>
+          <a:prstGeom prst="rect">
+            <a:avLst/>
+          </a:prstGeom>
+          <a:noFill/>
+        </p:spPr>
+        <p:txBody>
+          <a:bodyPr wrap="square">
+            <a:spAutoFit/>
+          </a:bodyPr>
+          <a:lstStyle/>
+          <a:p>
+            <a:pPr lvl="0">
+              <a:buNone/>
+            </a:pPr>
+            <a:r>
+              <a:rPr b="1">
+                <a:solidFill>
+                  <a:srgbClr val="00B050"/>
+                </a:solidFill>
+              </a:rPr>
+              <a:t>Anonymous Donation Check Box</a:t>
+            </a:r>
+          </a:p>
+          <a:p>
+            <a:pPr lvl="0">
+              <a:buNone/>
+            </a:pPr>
+            <a:r>
+              <a:rPr b="1">
+                <a:solidFill>
+                  <a:srgbClr val="00B050"/>
+                </a:solidFill>
+              </a:rPr>
+              <a:t>Present</a:t>
+            </a:r>
+          </a:p>
+        </p:txBody>
+      </p:sp>
+      <p:sp>
+        <p:nvSpPr>
+          <p:cNvPr id="4" name="TextBox 3"/>
+          <p:cNvSpPr txBox="1"/>
+          <p:nvPr/>
+        </p:nvSpPr>
+        <p:spPr>
+          <a:xfrm>
+            <a:off x="1571579" y="2753989"/>
+            <a:ext cx="1552559" cy="1200332"/>
+          </a:xfrm>
+          <a:prstGeom prst="rect">
+            <a:avLst/>
+          </a:prstGeom>
+          <a:noFill/>
+        </p:spPr>
+        <p:txBody>
+          <a:bodyPr wrap="square">
+            <a:spAutoFit/>
+          </a:bodyPr>
+          <a:lstStyle/>
+          <a:p>
+            <a:pPr>
+              <a:buNone/>
+            </a:pPr>
+            <a:r>
+              <a:rPr b="1">
+                <a:solidFill>
+                  <a:srgbClr val="FFC000"/>
+                </a:solidFill>
+              </a:rPr>
+              <a:t>Anonymous Donation Check Box Missing</a:t>
+            </a:r>
+          </a:p>
+        </p:txBody>
+      </p:sp>
+      <p:sp>
+        <p:nvSpPr>
+          <p:cNvPr id="5" name="leftBrace 4"/>
+          <p:cNvSpPr/>
+          <p:nvPr/>
+        </p:nvSpPr>
+        <p:spPr>
+          <a:xfrm>
+            <a:off x="2847990" y="2609880"/>
+            <a:ext cx="276240" cy="1438259"/>
+          </a:xfrm>
+          <a:prstGeom prst="leftBrace">
+            <a:avLst/>
+          </a:prstGeom>
+        </p:spPr>
+        <p:style>
+          <a:lnRef idx="1">
+            <a:schemeClr val="accent1"/>
+          </a:lnRef>
+          <a:fillRef idx="1">
+            <a:schemeClr val="accent1"/>
+          </a:fillRef>
+          <a:effectRef idx="2">
+            <a:schemeClr val="accent1"/>
+          </a:effectRef>
+          <a:fontRef idx="minor">
+            <a:schemeClr val="lt1"/>
+          </a:fontRef>
+        </p:style>
+        <p:txBody>
+          <a:bodyPr rtlCol="0" anchor="ctr"/>
+          <a:lstStyle/>
+          <a:p>
+            <a:pPr algn="ctr"/>
+          </a:p>
+        </p:txBody>
+      </p:sp>
+      <p:sp>
+        <p:nvSpPr>
+          <p:cNvPr id="6" name="leftBrace 5"/>
+          <p:cNvSpPr/>
+          <p:nvPr/>
+        </p:nvSpPr>
+        <p:spPr>
+          <a:xfrm>
+            <a:off x="2871490" y="509595"/>
+            <a:ext cx="276240" cy="1438259"/>
+          </a:xfrm>
+          <a:prstGeom prst="leftBrace">
+            <a:avLst/>
+          </a:prstGeom>
+        </p:spPr>
+        <p:style>
+          <a:lnRef idx="1">
+            <a:schemeClr val="accent1"/>
+          </a:lnRef>
+          <a:fillRef idx="1">
+            <a:schemeClr val="accent1"/>
+          </a:fillRef>
+          <a:effectRef idx="2">
+            <a:schemeClr val="accent1"/>
+          </a:effectRef>
+          <a:fontRef idx="minor">
+            <a:schemeClr val="lt1"/>
+          </a:fontRef>
+        </p:style>
+        <p:txBody>
+          <a:bodyPr rtlCol="0" anchor="ctr"/>
+          <a:lstStyle/>
+          <a:p>
+            <a:pPr algn="ctr"/>
+          </a:p>
+        </p:txBody>
+      </p:sp>
+      <p:sp>
+        <p:nvSpPr>
+          <p:cNvPr id="7" name="leftBrace 6"/>
+          <p:cNvSpPr/>
+          <p:nvPr/>
+        </p:nvSpPr>
+        <p:spPr>
+          <a:xfrm>
+            <a:off x="2885480" y="4297405"/>
+            <a:ext cx="276240" cy="2050999"/>
+          </a:xfrm>
+          <a:prstGeom prst="leftBrace">
+            <a:avLst/>
+          </a:prstGeom>
+        </p:spPr>
+        <p:style>
+          <a:lnRef idx="1">
+            <a:schemeClr val="accent1"/>
+          </a:lnRef>
+          <a:fillRef idx="1">
+            <a:schemeClr val="accent1"/>
+          </a:fillRef>
+          <a:effectRef idx="2">
+            <a:schemeClr val="accent1"/>
+          </a:effectRef>
+          <a:fontRef idx="minor">
+            <a:schemeClr val="lt1"/>
+          </a:fontRef>
+        </p:style>
+        <p:txBody>
+          <a:bodyPr rtlCol="0" anchor="ctr"/>
+          <a:lstStyle/>
+          <a:p>
+            <a:pPr algn="ctr"/>
+          </a:p>
+        </p:txBody>
+      </p:sp>
       <p:pic>
         <p:nvPicPr>
-          <p:cNvPr id="2" name="Picture 1" descr="image1.png"/>
+          <p:cNvPr id="8" name="Picture 7" descr="image1.png"/>
           <p:cNvPicPr>
             <a:picLocks noChangeAspect="1"/>
           </p:cNvPicPr>
@@ -3105,7 +3576,7 @@
         </p:blipFill>
         <p:spPr>
           <a:xfrm>
-            <a:off x="3124200" y="457200"/>
+            <a:off x="3124230" y="457200"/>
             <a:ext cx="5943600" cy="5943600"/>
           </a:xfrm>
           <a:prstGeom prst="rect">
@@ -3113,234 +3584,6 @@
           </a:prstGeom>
         </p:spPr>
       </p:pic>
-      <p:sp>
-        <p:nvSpPr>
-          <p:cNvPr id="3" name="Rectangle 2"/>
-          <p:cNvSpPr/>
-          <p:nvPr/>
-        </p:nvSpPr>
-        <p:spPr>
-          <a:xfrm>
-            <a:off x="1595145" y="628560"/>
-            <a:ext cx="1552575" cy="1200329"/>
-          </a:xfrm>
-          <a:prstGeom prst="rect">
-            <a:avLst/>
-          </a:prstGeom>
-        </p:spPr>
-        <p:style>
-          <a:lnRef idx="1">
-            <a:schemeClr val="accent1"/>
-          </a:lnRef>
-          <a:fillRef idx="3">
-            <a:schemeClr val="accent1"/>
-          </a:fillRef>
-          <a:effectRef idx="2">
-            <a:schemeClr val="accent1"/>
-          </a:effectRef>
-          <a:fontRef idx="minor">
-            <a:schemeClr val="lt1"/>
-          </a:fontRef>
-        </p:style>
-        <p:txBody>
-          <a:bodyPr rtlCol="0" anchor="ctr"/>
-          <a:lstStyle/>
-          <a:p>
-            <a:r>
-              <a:t>Anonymous Donation Check BoxPresent</a:t>
-            </a:r>
-          </a:p>
-        </p:txBody>
-      </p:sp>
-      <p:sp>
-        <p:nvSpPr>
-          <p:cNvPr id="4" name="Rectangle 3"/>
-          <p:cNvSpPr/>
-          <p:nvPr/>
-        </p:nvSpPr>
-        <p:spPr>
-          <a:xfrm>
-            <a:off x="1571625" y="4734275"/>
-            <a:ext cx="1552575" cy="1200329"/>
-          </a:xfrm>
-          <a:prstGeom prst="rect">
-            <a:avLst/>
-          </a:prstGeom>
-        </p:spPr>
-        <p:style>
-          <a:lnRef idx="1">
-            <a:schemeClr val="accent1"/>
-          </a:lnRef>
-          <a:fillRef idx="3">
-            <a:schemeClr val="accent1"/>
-          </a:fillRef>
-          <a:effectRef idx="2">
-            <a:schemeClr val="accent1"/>
-          </a:effectRef>
-          <a:fontRef idx="minor">
-            <a:schemeClr val="lt1"/>
-          </a:fontRef>
-        </p:style>
-        <p:txBody>
-          <a:bodyPr rtlCol="0" anchor="ctr"/>
-          <a:lstStyle/>
-          <a:p>
-            <a:r>
-              <a:t>Anonymous Donation Check BoxPresent</a:t>
-            </a:r>
-          </a:p>
-        </p:txBody>
-      </p:sp>
-      <p:sp>
-        <p:nvSpPr>
-          <p:cNvPr id="5" name="Rectangle 4"/>
-          <p:cNvSpPr/>
-          <p:nvPr/>
-        </p:nvSpPr>
-        <p:spPr>
-          <a:xfrm>
-            <a:off x="1571624" y="2753965"/>
-            <a:ext cx="1552575" cy="1200329"/>
-          </a:xfrm>
-          <a:prstGeom prst="rect">
-            <a:avLst/>
-          </a:prstGeom>
-        </p:spPr>
-        <p:style>
-          <a:lnRef idx="1">
-            <a:schemeClr val="accent1"/>
-          </a:lnRef>
-          <a:fillRef idx="3">
-            <a:schemeClr val="accent1"/>
-          </a:fillRef>
-          <a:effectRef idx="2">
-            <a:schemeClr val="accent1"/>
-          </a:effectRef>
-          <a:fontRef idx="minor">
-            <a:schemeClr val="lt1"/>
-          </a:fontRef>
-        </p:style>
-        <p:txBody>
-          <a:bodyPr rtlCol="0" anchor="ctr"/>
-          <a:lstStyle/>
-          <a:p>
-            <a:r>
-              <a:t>Anonymous Donation Check Box Missing</a:t>
-            </a:r>
-          </a:p>
-        </p:txBody>
-      </p:sp>
-      <p:sp>
-        <p:nvSpPr>
-          <p:cNvPr id="6" name="leftBrace 5"/>
-          <p:cNvSpPr/>
-          <p:nvPr/>
-        </p:nvSpPr>
-        <p:spPr>
-          <a:xfrm>
-            <a:off x="2847975" y="2609850"/>
-            <a:ext cx="276225" cy="1438275"/>
-          </a:xfrm>
-          <a:prstGeom prst="leftBrace">
-            <a:avLst/>
-          </a:prstGeom>
-        </p:spPr>
-        <p:style>
-          <a:lnRef idx="1">
-            <a:schemeClr val="accent1"/>
-          </a:lnRef>
-          <a:fillRef idx="3">
-            <a:schemeClr val="accent1"/>
-          </a:fillRef>
-          <a:effectRef idx="2">
-            <a:schemeClr val="accent1"/>
-          </a:effectRef>
-          <a:fontRef idx="minor">
-            <a:schemeClr val="lt1"/>
-          </a:fontRef>
-        </p:style>
-        <p:txBody>
-          <a:bodyPr rtlCol="0" anchor="ctr"/>
-          <a:lstStyle/>
-          <a:p>
-            <a:pPr algn="ctr"/>
-          </a:p>
-        </p:txBody>
-      </p:sp>
-      <p:sp>
-        <p:nvSpPr>
-          <p:cNvPr id="7" name="leftBrace 6"/>
-          <p:cNvSpPr/>
-          <p:nvPr/>
-        </p:nvSpPr>
-        <p:spPr>
-          <a:xfrm>
-            <a:off x="2871495" y="509588"/>
-            <a:ext cx="276225" cy="1438275"/>
-          </a:xfrm>
-          <a:prstGeom prst="leftBrace">
-            <a:avLst/>
-          </a:prstGeom>
-        </p:spPr>
-        <p:style>
-          <a:lnRef idx="1">
-            <a:schemeClr val="accent1"/>
-          </a:lnRef>
-          <a:fillRef idx="3">
-            <a:schemeClr val="accent1"/>
-          </a:fillRef>
-          <a:effectRef idx="2">
-            <a:schemeClr val="accent1"/>
-          </a:effectRef>
-          <a:fontRef idx="minor">
-            <a:schemeClr val="lt1"/>
-          </a:fontRef>
-        </p:style>
-        <p:txBody>
-          <a:bodyPr rtlCol="0" anchor="ctr"/>
-          <a:lstStyle/>
-          <a:p>
-            <a:pPr algn="ctr"/>
-          </a:p>
-        </p:txBody>
-      </p:sp>
-      <p:sp>
-        <p:nvSpPr>
-          <p:cNvPr id="8" name="leftBrace 7"/>
-          <p:cNvSpPr/>
-          <p:nvPr/>
-        </p:nvSpPr>
-        <p:spPr>
-          <a:xfrm>
-            <a:off x="2885489" y="4297369"/>
-            <a:ext cx="276225" cy="2051043"/>
-          </a:xfrm>
-          <a:prstGeom prst="leftBrace">
-            <a:avLst/>
-          </a:prstGeom>
-        </p:spPr>
-        <p:style>
-          <a:lnRef idx="1">
-            <a:schemeClr val="accent1"/>
-          </a:lnRef>
-          <a:fillRef idx="3">
-            <a:schemeClr val="accent1"/>
-          </a:fillRef>
-          <a:effectRef idx="2">
-            <a:schemeClr val="accent1"/>
-          </a:effectRef>
-          <a:fontRef idx="minor">
-            <a:schemeClr val="lt1"/>
-          </a:fontRef>
-        </p:style>
-        <p:txBody>
-          <a:bodyPr rtlCol="0" anchor="ctr"/>
-          <a:lstStyle/>
-          <a:p>
-            <a:pPr algn="ctr"/>
-          </a:p>
-        </p:txBody>
-      </p:sp>
     </p:spTree>
   </p:cSld>
   <p:clrMapOvr>
@@ -3359,9 +3602,208 @@
         <p:nvPr/>
       </p:nvGrpSpPr>
       <p:grpSpPr/>
+      <p:sp>
+        <p:nvSpPr>
+          <p:cNvPr id="2" name="TextBox 1"/>
+          <p:cNvSpPr txBox="1"/>
+          <p:nvPr/>
+        </p:nvSpPr>
+        <p:spPr>
+          <a:xfrm>
+            <a:off x="1604680" y="582930"/>
+            <a:ext cx="1552559" cy="1200332"/>
+          </a:xfrm>
+          <a:prstGeom prst="rect">
+            <a:avLst/>
+          </a:prstGeom>
+          <a:noFill/>
+        </p:spPr>
+        <p:txBody>
+          <a:bodyPr wrap="square">
+            <a:spAutoFit/>
+          </a:bodyPr>
+          <a:lstStyle/>
+          <a:p>
+            <a:pPr lvl="0">
+              <a:buNone/>
+            </a:pPr>
+            <a:r>
+              <a:rPr b="1">
+                <a:solidFill>
+                  <a:srgbClr val="00B050"/>
+                </a:solidFill>
+              </a:rPr>
+              <a:t>Anonymous Donation Check Box</a:t>
+            </a:r>
+          </a:p>
+          <a:p>
+            <a:pPr lvl="0">
+              <a:buNone/>
+            </a:pPr>
+            <a:r>
+              <a:rPr b="1">
+                <a:solidFill>
+                  <a:srgbClr val="00B050"/>
+                </a:solidFill>
+              </a:rPr>
+              <a:t>Present</a:t>
+            </a:r>
+          </a:p>
+        </p:txBody>
+      </p:sp>
+      <p:sp>
+        <p:nvSpPr>
+          <p:cNvPr id="3" name="leftBrace 2"/>
+          <p:cNvSpPr/>
+          <p:nvPr/>
+        </p:nvSpPr>
+        <p:spPr>
+          <a:xfrm>
+            <a:off x="2776209" y="554309"/>
+            <a:ext cx="408371" cy="1234440"/>
+          </a:xfrm>
+          <a:prstGeom prst="leftBrace">
+            <a:avLst/>
+          </a:prstGeom>
+        </p:spPr>
+        <p:style>
+          <a:lnRef idx="1">
+            <a:schemeClr val="accent1"/>
+          </a:lnRef>
+          <a:fillRef idx="1">
+            <a:schemeClr val="accent1"/>
+          </a:fillRef>
+          <a:effectRef idx="2">
+            <a:schemeClr val="accent1"/>
+          </a:effectRef>
+          <a:fontRef idx="minor">
+            <a:schemeClr val="lt1"/>
+          </a:fontRef>
+        </p:style>
+        <p:txBody>
+          <a:bodyPr rtlCol="0" anchor="ctr"/>
+          <a:lstStyle/>
+          <a:p>
+            <a:pPr algn="ctr"/>
+          </a:p>
+        </p:txBody>
+      </p:sp>
+      <p:sp>
+        <p:nvSpPr>
+          <p:cNvPr id="4" name="Rectangle 3"/>
+          <p:cNvSpPr/>
+          <p:nvPr/>
+        </p:nvSpPr>
+        <p:spPr>
+          <a:xfrm>
+            <a:off x="3157240" y="582930"/>
+            <a:ext cx="3310219" cy="293339"/>
+          </a:xfrm>
+          <a:prstGeom prst="rect">
+            <a:avLst/>
+          </a:prstGeom>
+          <a:noFill/>
+        </p:spPr>
+        <p:style>
+          <a:lnRef idx="2">
+            <a:schemeClr val="accent1">
+              <a:shade val="50000"/>
+            </a:schemeClr>
+          </a:lnRef>
+          <a:fillRef idx="1">
+            <a:schemeClr val="accent1"/>
+          </a:fillRef>
+          <a:effectRef idx="0">
+            <a:schemeClr val="accent1"/>
+          </a:effectRef>
+          <a:fontRef idx="minor">
+            <a:schemeClr val="lt1"/>
+          </a:fontRef>
+        </p:style>
+        <p:txBody>
+          <a:bodyPr rtlCol="0" anchor="ctr"/>
+          <a:lstStyle/>
+          <a:p>
+            <a:pPr algn="ctr"/>
+          </a:p>
+        </p:txBody>
+      </p:sp>
+      <p:sp>
+        <p:nvSpPr>
+          <p:cNvPr id="5" name="TextBox 4"/>
+          <p:cNvSpPr txBox="1"/>
+          <p:nvPr/>
+        </p:nvSpPr>
+        <p:spPr>
+          <a:xfrm>
+            <a:off x="2033259" y="3044677"/>
+            <a:ext cx="1552559" cy="1200332"/>
+          </a:xfrm>
+          <a:prstGeom prst="rect">
+            <a:avLst/>
+          </a:prstGeom>
+          <a:noFill/>
+        </p:spPr>
+        <p:txBody>
+          <a:bodyPr wrap="square">
+            <a:spAutoFit/>
+          </a:bodyPr>
+          <a:lstStyle/>
+          <a:p>
+            <a:pPr>
+              <a:buNone/>
+            </a:pPr>
+            <a:r>
+              <a:rPr b="1">
+                <a:solidFill>
+                  <a:srgbClr val="FFC000"/>
+                </a:solidFill>
+              </a:rPr>
+              <a:t>Anonymous Donation Check Box Missing</a:t>
+            </a:r>
+          </a:p>
+        </p:txBody>
+      </p:sp>
+      <p:sp>
+        <p:nvSpPr>
+          <p:cNvPr id="6" name="leftBrace 5"/>
+          <p:cNvSpPr/>
+          <p:nvPr/>
+        </p:nvSpPr>
+        <p:spPr>
+          <a:xfrm>
+            <a:off x="3184580" y="3106491"/>
+            <a:ext cx="382219" cy="1081369"/>
+          </a:xfrm>
+          <a:prstGeom prst="leftBrace">
+            <a:avLst/>
+          </a:prstGeom>
+        </p:spPr>
+        <p:style>
+          <a:lnRef idx="1">
+            <a:schemeClr val="accent1"/>
+          </a:lnRef>
+          <a:fillRef idx="1">
+            <a:schemeClr val="accent1"/>
+          </a:fillRef>
+          <a:effectRef idx="2">
+            <a:schemeClr val="accent1"/>
+          </a:effectRef>
+          <a:fontRef idx="minor">
+            <a:schemeClr val="lt1"/>
+          </a:fontRef>
+        </p:style>
+        <p:txBody>
+          <a:bodyPr rtlCol="0" anchor="ctr"/>
+          <a:lstStyle/>
+          <a:p>
+            <a:pPr algn="ctr"/>
+          </a:p>
+        </p:txBody>
+      </p:sp>
       <p:pic>
         <p:nvPicPr>
-          <p:cNvPr id="2" name="Picture 1" descr="image2.png"/>
+          <p:cNvPr id="7" name="Picture 6" descr="image2.png"/>
           <p:cNvPicPr>
             <a:picLocks noChangeAspect="1"/>
           </p:cNvPicPr>
@@ -3375,7 +3817,7 @@
         </p:blipFill>
         <p:spPr>
           <a:xfrm>
-            <a:off x="3063949" y="611505"/>
+            <a:off x="3063971" y="611459"/>
             <a:ext cx="4549140" cy="1234440"/>
           </a:xfrm>
           <a:prstGeom prst="rect">
@@ -3383,122 +3825,9 @@
           </a:prstGeom>
         </p:spPr>
       </p:pic>
-      <p:sp>
-        <p:nvSpPr>
-          <p:cNvPr id="3" name="Rectangle 2"/>
-          <p:cNvSpPr/>
-          <p:nvPr/>
-        </p:nvSpPr>
-        <p:spPr>
-          <a:xfrm>
-            <a:off x="1604670" y="582926"/>
-            <a:ext cx="1552575" cy="1200329"/>
-          </a:xfrm>
-          <a:prstGeom prst="rect">
-            <a:avLst/>
-          </a:prstGeom>
-        </p:spPr>
-        <p:style>
-          <a:lnRef idx="1">
-            <a:schemeClr val="accent1"/>
-          </a:lnRef>
-          <a:fillRef idx="3">
-            <a:schemeClr val="accent1"/>
-          </a:fillRef>
-          <a:effectRef idx="2">
-            <a:schemeClr val="accent1"/>
-          </a:effectRef>
-          <a:fontRef idx="minor">
-            <a:schemeClr val="lt1"/>
-          </a:fontRef>
-        </p:style>
-        <p:txBody>
-          <a:bodyPr rtlCol="0" anchor="ctr"/>
-          <a:lstStyle/>
-          <a:p>
-            <a:r>
-              <a:t>Anonymous Donation Check BoxPresent</a:t>
-            </a:r>
-          </a:p>
-        </p:txBody>
-      </p:sp>
-      <p:sp>
-        <p:nvSpPr>
-          <p:cNvPr id="4" name="leftBrace 3"/>
-          <p:cNvSpPr/>
-          <p:nvPr/>
-        </p:nvSpPr>
-        <p:spPr>
-          <a:xfrm>
-            <a:off x="2776245" y="554355"/>
-            <a:ext cx="408371" cy="1234440"/>
-          </a:xfrm>
-          <a:prstGeom prst="leftBrace">
-            <a:avLst/>
-          </a:prstGeom>
-        </p:spPr>
-        <p:style>
-          <a:lnRef idx="1">
-            <a:schemeClr val="accent1"/>
-          </a:lnRef>
-          <a:fillRef idx="3">
-            <a:schemeClr val="accent1"/>
-          </a:fillRef>
-          <a:effectRef idx="2">
-            <a:schemeClr val="accent1"/>
-          </a:effectRef>
-          <a:fontRef idx="minor">
-            <a:schemeClr val="lt1"/>
-          </a:fontRef>
-        </p:style>
-        <p:txBody>
-          <a:bodyPr rtlCol="0" anchor="ctr"/>
-          <a:lstStyle/>
-          <a:p>
-            <a:pPr algn="ctr"/>
-          </a:p>
-        </p:txBody>
-      </p:sp>
-      <p:sp>
-        <p:nvSpPr>
-          <p:cNvPr id="5" name="Rectangle 4"/>
-          <p:cNvSpPr/>
-          <p:nvPr/>
-        </p:nvSpPr>
-        <p:spPr>
-          <a:xfrm>
-            <a:off x="3157245" y="582926"/>
-            <a:ext cx="3310230" cy="293374"/>
-          </a:xfrm>
-          <a:prstGeom prst="rect">
-            <a:avLst/>
-          </a:prstGeom>
-        </p:spPr>
-        <p:style>
-          <a:lnRef idx="1">
-            <a:schemeClr val="accent1"/>
-          </a:lnRef>
-          <a:fillRef idx="3">
-            <a:schemeClr val="accent1"/>
-          </a:fillRef>
-          <a:effectRef idx="2">
-            <a:schemeClr val="accent1"/>
-          </a:effectRef>
-          <a:fontRef idx="minor">
-            <a:schemeClr val="lt1"/>
-          </a:fontRef>
-        </p:style>
-        <p:txBody>
-          <a:bodyPr rtlCol="0" anchor="ctr"/>
-          <a:lstStyle/>
-          <a:p>
-            <a:pPr algn="ctr"/>
-          </a:p>
-        </p:txBody>
-      </p:sp>
       <p:pic>
         <p:nvPicPr>
-          <p:cNvPr id="6" name="Picture 5" descr="image3.png"/>
+          <p:cNvPr id="8" name="Picture 7" descr="image3.png"/>
           <p:cNvPicPr>
             <a:picLocks noChangeAspect="1"/>
           </p:cNvPicPr>
@@ -3506,96 +3835,21 @@
         </p:nvPicPr>
         <p:blipFill>
           <a:blip r:embed="rId3"/>
+          <a:srcRect t="3311" r="1631"/>
           <a:stretch>
             <a:fillRect/>
           </a:stretch>
         </p:blipFill>
         <p:spPr>
           <a:xfrm>
-            <a:off x="3279866" y="3096154"/>
-            <a:ext cx="4333223" cy="1234440"/>
+            <a:off x="3279861" y="3096158"/>
+            <a:ext cx="4333250" cy="1234440"/>
           </a:xfrm>
           <a:prstGeom prst="rect">
             <a:avLst/>
           </a:prstGeom>
         </p:spPr>
       </p:pic>
-      <p:sp>
-        <p:nvSpPr>
-          <p:cNvPr id="7" name="Rectangle 6"/>
-          <p:cNvSpPr/>
-          <p:nvPr/>
-        </p:nvSpPr>
-        <p:spPr>
-          <a:xfrm>
-            <a:off x="2033295" y="3044633"/>
-            <a:ext cx="1552575" cy="1200329"/>
-          </a:xfrm>
-          <a:prstGeom prst="rect">
-            <a:avLst/>
-          </a:prstGeom>
-        </p:spPr>
-        <p:style>
-          <a:lnRef idx="1">
-            <a:schemeClr val="accent1"/>
-          </a:lnRef>
-          <a:fillRef idx="3">
-            <a:schemeClr val="accent1"/>
-          </a:fillRef>
-          <a:effectRef idx="2">
-            <a:schemeClr val="accent1"/>
-          </a:effectRef>
-          <a:fontRef idx="minor">
-            <a:schemeClr val="lt1"/>
-          </a:fontRef>
-        </p:style>
-        <p:txBody>
-          <a:bodyPr rtlCol="0" anchor="ctr"/>
-          <a:lstStyle/>
-          <a:p>
-            <a:r>
-              <a:t>Anonymous Donation Check Box Missing</a:t>
-            </a:r>
-          </a:p>
-        </p:txBody>
-      </p:sp>
-      <p:sp>
-        <p:nvSpPr>
-          <p:cNvPr id="8" name="leftBrace 7"/>
-          <p:cNvSpPr/>
-          <p:nvPr/>
-        </p:nvSpPr>
-        <p:spPr>
-          <a:xfrm>
-            <a:off x="3184616" y="3106455"/>
-            <a:ext cx="382204" cy="1081357"/>
-          </a:xfrm>
-          <a:prstGeom prst="leftBrace">
-            <a:avLst/>
-          </a:prstGeom>
-        </p:spPr>
-        <p:style>
-          <a:lnRef idx="1">
-            <a:schemeClr val="accent1"/>
-          </a:lnRef>
-          <a:fillRef idx="3">
-            <a:schemeClr val="accent1"/>
-          </a:fillRef>
-          <a:effectRef idx="2">
-            <a:schemeClr val="accent1"/>
-          </a:effectRef>
-          <a:fontRef idx="minor">
-            <a:schemeClr val="lt1"/>
-          </a:fontRef>
-        </p:style>
-        <p:txBody>
-          <a:bodyPr rtlCol="0" anchor="ctr"/>
-          <a:lstStyle/>
-          <a:p>
-            <a:pPr algn="ctr"/>
-          </a:p>
-        </p:txBody>
-      </p:sp>
     </p:spTree>
   </p:cSld>
   <p:clrMapOvr>
@@ -3615,44 +3869,44 @@
         <a:sysClr val="window" lastClr="FFFFFF"/>
       </a:lt1>
       <a:dk2>
-        <a:srgbClr val="1F497D"/>
+        <a:srgbClr val="44546A"/>
       </a:dk2>
       <a:lt2>
-        <a:srgbClr val="EEECE1"/>
+        <a:srgbClr val="E7E6E6"/>
       </a:lt2>
       <a:accent1>
-        <a:srgbClr val="4F81BD"/>
+        <a:srgbClr val="4472C4"/>
       </a:accent1>
       <a:accent2>
-        <a:srgbClr val="C0504D"/>
+        <a:srgbClr val="ED7D31"/>
       </a:accent2>
       <a:accent3>
-        <a:srgbClr val="9BBB59"/>
+        <a:srgbClr val="A5A5A5"/>
       </a:accent3>
       <a:accent4>
-        <a:srgbClr val="8064A2"/>
+        <a:srgbClr val="FFC000"/>
       </a:accent4>
       <a:accent5>
-        <a:srgbClr val="4BACC6"/>
+        <a:srgbClr val="5B9BD5"/>
       </a:accent5>
       <a:accent6>
-        <a:srgbClr val="F79646"/>
+        <a:srgbClr val="70AD47"/>
       </a:accent6>
       <a:hlink>
-        <a:srgbClr val="0000FF"/>
+        <a:srgbClr val="0563C1"/>
       </a:hlink>
       <a:folHlink>
-        <a:srgbClr val="800080"/>
+        <a:srgbClr val="954F72"/>
       </a:folHlink>
     </a:clrScheme>
     <a:fontScheme name="Office">
       <a:majorFont>
-        <a:latin typeface="Calibri"/>
+        <a:latin typeface="Calibri Light" panose="020F0302020204030204"/>
         <a:ea typeface=""/>
         <a:cs typeface=""/>
-        <a:font script="Jpan" typeface="ＭＳ Ｐゴシック"/>
+        <a:font script="Jpan" typeface="游ゴシック Light"/>
         <a:font script="Hang" typeface="맑은 고딕"/>
-        <a:font script="Hans" typeface="宋体"/>
+        <a:font script="Hans" typeface="等线 Light"/>
         <a:font script="Hant" typeface="新細明體"/>
         <a:font script="Arab" typeface="Times New Roman"/>
         <a:font script="Hebr" typeface="Times New Roman"/>
@@ -3680,14 +3934,31 @@
         <a:font script="Viet" typeface="Times New Roman"/>
         <a:font script="Uigh" typeface="Microsoft Uighur"/>
         <a:font script="Geor" typeface="Sylfaen"/>
+        <a:font script="Armn" typeface="Arial"/>
+        <a:font script="Bugi" typeface="Leelawadee UI"/>
+        <a:font script="Bopo" typeface="Microsoft JhengHei"/>
+        <a:font script="Java" typeface="Javanese Text"/>
+        <a:font script="Lisu" typeface="Segoe UI"/>
+        <a:font script="Mymr" typeface="Myanmar Text"/>
+        <a:font script="Nkoo" typeface="Ebrima"/>
+        <a:font script="Olck" typeface="Nirmala UI"/>
+        <a:font script="Osma" typeface="Ebrima"/>
+        <a:font script="Phag" typeface="Phagspa"/>
+        <a:font script="Syrn" typeface="Estrangelo Edessa"/>
+        <a:font script="Syrj" typeface="Estrangelo Edessa"/>
+        <a:font script="Syre" typeface="Estrangelo Edessa"/>
+        <a:font script="Sora" typeface="Nirmala UI"/>
+        <a:font script="Tale" typeface="Microsoft Tai Le"/>
+        <a:font script="Talu" typeface="Microsoft New Tai Lue"/>
+        <a:font script="Tfng" typeface="Ebrima"/>
       </a:majorFont>
       <a:minorFont>
-        <a:latin typeface="Calibri"/>
+        <a:latin typeface="Calibri" panose="020F0502020204030204"/>
         <a:ea typeface=""/>
         <a:cs typeface=""/>
-        <a:font script="Jpan" typeface="ＭＳ Ｐゴシック"/>
+        <a:font script="Jpan" typeface="游ゴシック"/>
         <a:font script="Hang" typeface="맑은 고딕"/>
-        <a:font script="Hans" typeface="宋体"/>
+        <a:font script="Hans" typeface="等线"/>
         <a:font script="Hant" typeface="新細明體"/>
         <a:font script="Arab" typeface="Arial"/>
         <a:font script="Hebr" typeface="Arial"/>
@@ -3715,6 +3986,23 @@
         <a:font script="Viet" typeface="Arial"/>
         <a:font script="Uigh" typeface="Microsoft Uighur"/>
         <a:font script="Geor" typeface="Sylfaen"/>
+        <a:font script="Armn" typeface="Arial"/>
+        <a:font script="Bugi" typeface="Leelawadee UI"/>
+        <a:font script="Bopo" typeface="Microsoft JhengHei"/>
+        <a:font script="Java" typeface="Javanese Text"/>
+        <a:font script="Lisu" typeface="Segoe UI"/>
+        <a:font script="Mymr" typeface="Myanmar Text"/>
+        <a:font script="Nkoo" typeface="Ebrima"/>
+        <a:font script="Olck" typeface="Nirmala UI"/>
+        <a:font script="Osma" typeface="Ebrima"/>
+        <a:font script="Phag" typeface="Phagspa"/>
+        <a:font script="Syrn" typeface="Estrangelo Edessa"/>
+        <a:font script="Syrj" typeface="Estrangelo Edessa"/>
+        <a:font script="Syre" typeface="Estrangelo Edessa"/>
+        <a:font script="Sora" typeface="Nirmala UI"/>
+        <a:font script="Tale" typeface="Microsoft Tai Le"/>
+        <a:font script="Talu" typeface="Microsoft New Tai Lue"/>
+        <a:font script="Tfng" typeface="Ebrima"/>
       </a:minorFont>
     </a:fontScheme>
     <a:fmtScheme name="Office">
@@ -3726,200 +4014,141 @@
           <a:gsLst>
             <a:gs pos="0">
               <a:schemeClr val="phClr">
-                <a:tint val="50000"/>
-                <a:satMod val="300000"/>
+                <a:lumMod val="110000"/>
+                <a:satMod val="105000"/>
+                <a:tint val="67000"/>
               </a:schemeClr>
             </a:gs>
-            <a:gs pos="35000">
+            <a:gs pos="50000">
               <a:schemeClr val="phClr">
-                <a:tint val="37000"/>
-                <a:satMod val="300000"/>
+                <a:lumMod val="105000"/>
+                <a:satMod val="103000"/>
+                <a:tint val="73000"/>
               </a:schemeClr>
             </a:gs>
             <a:gs pos="100000">
               <a:schemeClr val="phClr">
-                <a:tint val="15000"/>
-                <a:satMod val="350000"/>
+                <a:lumMod val="105000"/>
+                <a:satMod val="109000"/>
+                <a:tint val="81000"/>
               </a:schemeClr>
             </a:gs>
           </a:gsLst>
-          <a:lin ang="16200000" scaled="1"/>
+          <a:lin ang="5400000" scaled="0"/>
         </a:gradFill>
         <a:gradFill rotWithShape="1">
           <a:gsLst>
             <a:gs pos="0">
               <a:schemeClr val="phClr">
-                <a:tint val="100000"/>
+                <a:satMod val="103000"/>
+                <a:lumMod val="102000"/>
+                <a:tint val="94000"/>
+              </a:schemeClr>
+            </a:gs>
+            <a:gs pos="50000">
+              <a:schemeClr val="phClr">
+                <a:satMod val="110000"/>
+                <a:lumMod val="100000"/>
                 <a:shade val="100000"/>
-                <a:satMod val="130000"/>
               </a:schemeClr>
             </a:gs>
             <a:gs pos="100000">
               <a:schemeClr val="phClr">
-                <a:tint val="50000"/>
-                <a:shade val="100000"/>
-                <a:satMod val="350000"/>
+                <a:lumMod val="99000"/>
+                <a:satMod val="120000"/>
+                <a:shade val="78000"/>
               </a:schemeClr>
             </a:gs>
           </a:gsLst>
-          <a:lin ang="16200000" scaled="0"/>
+          <a:lin ang="5400000" scaled="0"/>
         </a:gradFill>
       </a:fillStyleLst>
       <a:lnStyleLst>
-        <a:ln w="9525" cap="flat" cmpd="sng" algn="ctr">
-          <a:solidFill>
-            <a:schemeClr val="phClr">
-              <a:shade val="95000"/>
-              <a:satMod val="105000"/>
-            </a:schemeClr>
-          </a:solidFill>
-          <a:prstDash val="solid"/>
-        </a:ln>
-        <a:ln w="25400" cap="flat" cmpd="sng" algn="ctr">
+        <a:ln w="6350" cap="flat" cmpd="sng" algn="ctr">
           <a:solidFill>
             <a:schemeClr val="phClr"/>
           </a:solidFill>
           <a:prstDash val="solid"/>
+          <a:miter lim="800000"/>
         </a:ln>
-        <a:ln w="38100" cap="flat" cmpd="sng" algn="ctr">
+        <a:ln w="12700" cap="flat" cmpd="sng" algn="ctr">
           <a:solidFill>
             <a:schemeClr val="phClr"/>
           </a:solidFill>
           <a:prstDash val="solid"/>
+          <a:miter lim="800000"/>
+        </a:ln>
+        <a:ln w="19050" cap="flat" cmpd="sng" algn="ctr">
+          <a:solidFill>
+            <a:schemeClr val="phClr"/>
+          </a:solidFill>
+          <a:prstDash val="solid"/>
+          <a:miter lim="800000"/>
         </a:ln>
       </a:lnStyleLst>
       <a:effectStyleLst>
         <a:effectStyle>
+          <a:effectLst/>
+        </a:effectStyle>
+        <a:effectStyle>
+          <a:effectLst/>
+        </a:effectStyle>
+        <a:effectStyle>
           <a:effectLst>
-            <a:outerShdw blurRad="40000" dist="20000" dir="5400000" rotWithShape="0">
+            <a:outerShdw blurRad="57150" dist="19050" dir="5400000" algn="ctr" rotWithShape="0">
               <a:srgbClr val="000000">
-                <a:alpha val="38000"/>
+                <a:alpha val="63000"/>
               </a:srgbClr>
             </a:outerShdw>
           </a:effectLst>
-        </a:effectStyle>
-        <a:effectStyle>
-          <a:effectLst>
-            <a:outerShdw blurRad="40000" dist="23000" dir="5400000" rotWithShape="0">
-              <a:srgbClr val="000000">
-                <a:alpha val="35000"/>
-              </a:srgbClr>
-            </a:outerShdw>
-          </a:effectLst>
-        </a:effectStyle>
-        <a:effectStyle>
-          <a:effectLst>
-            <a:outerShdw blurRad="40000" dist="23000" dir="5400000" rotWithShape="0">
-              <a:srgbClr val="000000">
-                <a:alpha val="35000"/>
-              </a:srgbClr>
-            </a:outerShdw>
-          </a:effectLst>
-          <a:scene3d>
-            <a:camera prst="orthographicFront">
-              <a:rot lat="0" lon="0" rev="0"/>
-            </a:camera>
-            <a:lightRig rig="threePt" dir="t">
-              <a:rot lat="0" lon="0" rev="1200000"/>
-            </a:lightRig>
-          </a:scene3d>
-          <a:sp3d>
-            <a:bevelT w="63500" h="25400"/>
-          </a:sp3d>
         </a:effectStyle>
       </a:effectStyleLst>
       <a:bgFillStyleLst>
         <a:solidFill>
           <a:schemeClr val="phClr"/>
         </a:solidFill>
+        <a:solidFill>
+          <a:schemeClr val="phClr">
+            <a:tint val="95000"/>
+            <a:satMod val="170000"/>
+          </a:schemeClr>
+        </a:solidFill>
         <a:gradFill rotWithShape="1">
           <a:gsLst>
             <a:gs pos="0">
               <a:schemeClr val="phClr">
-                <a:tint val="40000"/>
-                <a:satMod val="350000"/>
+                <a:tint val="93000"/>
+                <a:satMod val="150000"/>
+                <a:shade val="98000"/>
+                <a:lumMod val="102000"/>
               </a:schemeClr>
             </a:gs>
-            <a:gs pos="40000">
+            <a:gs pos="50000">
               <a:schemeClr val="phClr">
-                <a:tint val="45000"/>
-                <a:shade val="99000"/>
-                <a:satMod val="350000"/>
+                <a:tint val="98000"/>
+                <a:satMod val="130000"/>
+                <a:shade val="90000"/>
+                <a:lumMod val="103000"/>
               </a:schemeClr>
             </a:gs>
             <a:gs pos="100000">
               <a:schemeClr val="phClr">
-                <a:shade val="20000"/>
-                <a:satMod val="255000"/>
+                <a:shade val="63000"/>
+                <a:satMod val="120000"/>
               </a:schemeClr>
             </a:gs>
           </a:gsLst>
-          <a:path path="circle">
-            <a:fillToRect l="50000" t="-80000" r="50000" b="180000"/>
-          </a:path>
-        </a:gradFill>
-        <a:gradFill rotWithShape="1">
-          <a:gsLst>
-            <a:gs pos="0">
-              <a:schemeClr val="phClr">
-                <a:tint val="80000"/>
-                <a:satMod val="300000"/>
-              </a:schemeClr>
-            </a:gs>
-            <a:gs pos="100000">
-              <a:schemeClr val="phClr">
-                <a:shade val="30000"/>
-                <a:satMod val="200000"/>
-              </a:schemeClr>
-            </a:gs>
-          </a:gsLst>
-          <a:path path="circle">
-            <a:fillToRect l="50000" t="50000" r="50000" b="50000"/>
-          </a:path>
+          <a:lin ang="5400000" scaled="0"/>
         </a:gradFill>
       </a:bgFillStyleLst>
     </a:fmtScheme>
   </a:themeElements>
-  <a:objectDefaults>
-    <a:spDef>
-      <a:spPr/>
-      <a:bodyPr/>
-      <a:lstStyle/>
-      <a:style>
-        <a:lnRef idx="1">
-          <a:schemeClr val="accent1"/>
-        </a:lnRef>
-        <a:fillRef idx="3">
-          <a:schemeClr val="accent1"/>
-        </a:fillRef>
-        <a:effectRef idx="2">
-          <a:schemeClr val="accent1"/>
-        </a:effectRef>
-        <a:fontRef idx="minor">
-          <a:schemeClr val="lt1"/>
-        </a:fontRef>
-      </a:style>
-    </a:spDef>
-    <a:lnDef>
-      <a:spPr/>
-      <a:bodyPr/>
-      <a:lstStyle/>
-      <a:style>
-        <a:lnRef idx="2">
-          <a:schemeClr val="accent1"/>
-        </a:lnRef>
-        <a:fillRef idx="0">
-          <a:schemeClr val="accent1"/>
-        </a:fillRef>
-        <a:effectRef idx="1">
-          <a:schemeClr val="accent1"/>
-        </a:effectRef>
-        <a:fontRef idx="minor">
-          <a:schemeClr val="tx1"/>
-        </a:fontRef>
-      </a:style>
-    </a:lnDef>
-  </a:objectDefaults>
+  <a:objectDefaults/>
   <a:extraClrSchemeLst/>
+  <a:extLst>
+    <a:ext uri="{05A4C25C-085E-4340-85A3-A5531E510DB2}">
+      <thm15:themeFamily xmlns:thm15="http://schemas.microsoft.com/office/thememl/2012/main" name="Office Theme" id="{62F939B6-93AF-4DB8-9C6B-D6C7DFDC589F}" vid="{4A3C46E8-61CC-4603-A589-7422A47A8E4A}"/>
+    </a:ext>
+  </a:extLst>
 </a:theme>
 </file>
</xml_diff>